<commit_message>
fix(poster): resolve title/author overlap & hero caption overflow; re-crop robot, 3D map, mesh, Nav2 panels; rebalance right column
</commit_message>
<xml_diff>
--- a/ICCAS/poster/ICCAS2026_Poster_Quadruped.pptx
+++ b/ICCAS/poster/ICCAS2026_Poster_Quadruped.pptx
@@ -3144,8 +3144,8 @@
         </p:nvSpPr>
         <p:spPr>
           <a:xfrm>
-            <a:off x="720000" y="540000"/>
-            <a:ext cx="28835999" cy="1655999"/>
+            <a:off x="720000" y="576000"/>
+            <a:ext cx="28835999" cy="2088000"/>
           </a:xfrm>
           <a:prstGeom prst="rect">
             <a:avLst/>
@@ -3170,7 +3170,7 @@
               </a:spcAft>
             </a:pPr>
             <a:r>
-              <a:rPr sz="6600" b="1" i="0">
+              <a:rPr sz="6400" b="1" i="0">
                 <a:solidFill>
                   <a:srgbClr val="FFFFFF"/>
                 </a:solidFill>
@@ -3191,8 +3191,8 @@
         </p:nvSpPr>
         <p:spPr>
           <a:xfrm>
-            <a:off x="720000" y="2268000"/>
-            <a:ext cx="28835999" cy="503999"/>
+            <a:off x="720000" y="2736000"/>
+            <a:ext cx="28835999" cy="576000"/>
           </a:xfrm>
           <a:prstGeom prst="rect">
             <a:avLst/>
@@ -3315,8 +3315,8 @@
         </p:nvSpPr>
         <p:spPr>
           <a:xfrm>
-            <a:off x="720000" y="2844000"/>
-            <a:ext cx="28835999" cy="468000"/>
+            <a:off x="720000" y="3384000"/>
+            <a:ext cx="28835999" cy="432000"/>
           </a:xfrm>
           <a:prstGeom prst="rect">
             <a:avLst/>
@@ -3518,8 +3518,8 @@
         </p:blipFill>
         <p:spPr>
           <a:xfrm>
-            <a:off x="1547999" y="5400000"/>
-            <a:ext cx="27180000" cy="9756973"/>
+            <a:off x="1727999" y="5400000"/>
+            <a:ext cx="26820000" cy="9627741"/>
           </a:xfrm>
           <a:prstGeom prst="rect">
             <a:avLst/>
@@ -3534,8 +3534,8 @@
         </p:nvSpPr>
         <p:spPr>
           <a:xfrm>
-            <a:off x="936000" y="15192973"/>
-            <a:ext cx="28403999" cy="468000"/>
+            <a:off x="936000" y="15081741"/>
+            <a:ext cx="28403999" cy="360000"/>
           </a:xfrm>
           <a:prstGeom prst="rect">
             <a:avLst/>
@@ -3560,7 +3560,7 @@
               </a:spcAft>
             </a:pPr>
             <a:r>
-              <a:rPr sz="2300" b="1" i="0">
+              <a:rPr sz="2400" b="1" i="0">
                 <a:solidFill>
                   <a:srgbClr val="475569"/>
                 </a:solidFill>
@@ -3568,10 +3568,10 @@
                 <a:ea typeface="Arial"/>
                 <a:cs typeface="Arial"/>
               </a:rPr>
-              <a:t>Core Sim-to-Real Methodology:</a:t>
-            </a:r>
-            <a:r>
-              <a:rPr sz="2300" b="0" i="0">
+              <a:t>Key idea:</a:t>
+            </a:r>
+            <a:r>
+              <a:rPr sz="2400" b="0" i="0">
                 <a:solidFill>
                   <a:srgbClr val="475569"/>
                 </a:solidFill>
@@ -3579,7 +3579,7 @@
                 <a:ea typeface="Arial"/>
                 <a:cs typeface="Arial"/>
               </a:rPr>
-              <a:t> Virtual parameters optimized under simulated 3DGS photorealism &amp; RL gait bobbing noise (Phase B) transfer directly to the physical Unitree Go2 (Phase C). Hardware control routes commands to the built-in Sport API via a ROS 2 bridge, bypassing heavy RL computation on the Jetson Orin NX.</a:t>
+              <a:t> RTAB-Map &amp; Nav2 parameters tuned in the photorealistic 3DGS twin under RL gait bobbing (B) migrate directly to the physical Go2 (C) without retuning.</a:t>
             </a:r>
           </a:p>
         </p:txBody>
@@ -3959,8 +3959,8 @@
         </p:blipFill>
         <p:spPr>
           <a:xfrm>
-            <a:off x="2789999" y="22194000"/>
-            <a:ext cx="10080000" cy="4677494"/>
+            <a:off x="1259999" y="22194000"/>
+            <a:ext cx="13140000" cy="5010791"/>
           </a:xfrm>
           <a:prstGeom prst="rect">
             <a:avLst/>
@@ -3975,7 +3975,7 @@
         </p:nvSpPr>
         <p:spPr>
           <a:xfrm>
-            <a:off x="2915999" y="22284000"/>
+            <a:off x="1385999" y="22284000"/>
             <a:ext cx="3407040" cy="402480"/>
           </a:xfrm>
           <a:prstGeom prst="roundRect">
@@ -4079,8 +4079,8 @@
         </p:nvSpPr>
         <p:spPr>
           <a:xfrm>
-            <a:off x="936000" y="26979494"/>
-            <a:ext cx="13787999" cy="2918505"/>
+            <a:off x="936000" y="27312791"/>
+            <a:ext cx="13787999" cy="2585208"/>
           </a:xfrm>
           <a:prstGeom prst="rect">
             <a:avLst/>
@@ -4319,8 +4319,8 @@
         </p:blipFill>
         <p:spPr>
           <a:xfrm>
-            <a:off x="1169999" y="31320000"/>
-            <a:ext cx="13320000" cy="3505263"/>
+            <a:off x="936000" y="31320000"/>
+            <a:ext cx="13787999" cy="4258217"/>
           </a:xfrm>
           <a:prstGeom prst="rect">
             <a:avLst/>
@@ -4335,7 +4335,7 @@
         </p:nvSpPr>
         <p:spPr>
           <a:xfrm>
-            <a:off x="1295999" y="31410000"/>
+            <a:off x="1062000" y="31410000"/>
             <a:ext cx="4392000" cy="402480"/>
           </a:xfrm>
           <a:prstGeom prst="roundRect">
@@ -4387,7 +4387,7 @@
         </p:nvSpPr>
         <p:spPr>
           <a:xfrm>
-            <a:off x="7956000" y="31410000"/>
+            <a:off x="8457283" y="31410000"/>
             <a:ext cx="5376960" cy="402480"/>
           </a:xfrm>
           <a:prstGeom prst="roundRect">
@@ -4439,8 +4439,8 @@
         </p:nvSpPr>
         <p:spPr>
           <a:xfrm>
-            <a:off x="936000" y="34933263"/>
-            <a:ext cx="13787999" cy="4090736"/>
+            <a:off x="936000" y="35686217"/>
+            <a:ext cx="13787999" cy="3337782"/>
           </a:xfrm>
           <a:prstGeom prst="rect">
             <a:avLst/>
@@ -4553,7 +4553,7 @@
               <a:buChar char="■"/>
             </a:pPr>
             <a:r>
-              <a:rPr sz="2400" b="1" i="0">
+              <a:rPr sz="2500" b="1" i="0">
                 <a:solidFill>
                   <a:srgbClr val="0F172A"/>
                 </a:solidFill>
@@ -4564,7 +4564,7 @@
               <a:t>Nav2 Local Replanning:</a:t>
             </a:r>
             <a:r>
-              <a:rPr sz="2400" b="0" i="0">
+              <a:rPr sz="2500" b="0" i="0">
                 <a:solidFill>
                   <a:srgbClr val="0F172A"/>
                 </a:solidFill>
@@ -4586,7 +4586,7 @@
         <p:spPr>
           <a:xfrm>
             <a:off x="15336000" y="15947999"/>
-            <a:ext cx="14220000" cy="8856000"/>
+            <a:ext cx="14220000" cy="9504000"/>
           </a:xfrm>
           <a:prstGeom prst="roundRect">
             <a:avLst>
@@ -4679,8 +4679,8 @@
         </p:blipFill>
         <p:spPr>
           <a:xfrm>
-            <a:off x="17248131" y="16884000"/>
-            <a:ext cx="4021596" cy="4140000"/>
+            <a:off x="15723844" y="16884000"/>
+            <a:ext cx="5637446" cy="5760000"/>
           </a:xfrm>
           <a:prstGeom prst="rect">
             <a:avLst/>
@@ -4695,8 +4695,8 @@
         </p:nvSpPr>
         <p:spPr>
           <a:xfrm>
-            <a:off x="17320131" y="16956000"/>
-            <a:ext cx="2197440" cy="372240"/>
+            <a:off x="15813844" y="16974000"/>
+            <a:ext cx="3553920" cy="387360"/>
           </a:xfrm>
           <a:prstGeom prst="roundRect">
             <a:avLst>
@@ -4726,7 +4726,7 @@
               </a:spcAft>
             </a:pPr>
             <a:r>
-              <a:rPr sz="1700" b="1" i="0">
+              <a:rPr sz="1800" b="1" i="0">
                 <a:solidFill>
                   <a:srgbClr val="FFFFFF"/>
                 </a:solidFill>
@@ -4734,7 +4734,7 @@
                 <a:ea typeface="Arial"/>
                 <a:cs typeface="Arial"/>
               </a:rPr>
-              <a:t>Go2 + Orin NX</a:t>
+              <a:t>Go2 + D435i + Orin NX</a:t>
             </a:r>
           </a:p>
         </p:txBody>
@@ -4755,8 +4755,8 @@
         </p:blipFill>
         <p:spPr>
           <a:xfrm>
-            <a:off x="21485727" y="16884000"/>
-            <a:ext cx="5193630" cy="4140000"/>
+            <a:off x="21541290" y="16884000"/>
+            <a:ext cx="6470808" cy="5760000"/>
           </a:xfrm>
           <a:prstGeom prst="rect">
             <a:avLst/>
@@ -4771,8 +4771,8 @@
         </p:nvSpPr>
         <p:spPr>
           <a:xfrm>
-            <a:off x="21557727" y="16956000"/>
-            <a:ext cx="1903680" cy="372240"/>
+            <a:off x="21631290" y="16974000"/>
+            <a:ext cx="3864960" cy="387360"/>
           </a:xfrm>
           <a:prstGeom prst="roundRect">
             <a:avLst>
@@ -4802,7 +4802,7 @@
               </a:spcAft>
             </a:pPr>
             <a:r>
-              <a:rPr sz="1700" b="1" i="0">
+              <a:rPr sz="1800" b="1" i="0">
                 <a:solidFill>
                   <a:srgbClr val="FFFFFF"/>
                 </a:solidFill>
@@ -4810,7 +4810,7 @@
                 <a:ea typeface="Arial"/>
                 <a:cs typeface="Arial"/>
               </a:rPr>
-              <a:t>RTAB-Map 3D</a:t>
+              <a:t>RTAB-Map 3D Point Cloud</a:t>
             </a:r>
           </a:p>
         </p:txBody>
@@ -4831,8 +4831,8 @@
         </p:blipFill>
         <p:spPr>
           <a:xfrm>
-            <a:off x="26895357" y="16884000"/>
-            <a:ext cx="748511" cy="4140000"/>
+            <a:off x="28192099" y="17244000"/>
+            <a:ext cx="976056" cy="5400000"/>
           </a:xfrm>
           <a:prstGeom prst="rect">
             <a:avLst/>
@@ -4847,8 +4847,8 @@
         </p:nvSpPr>
         <p:spPr>
           <a:xfrm>
-            <a:off x="26823357" y="16956000"/>
-            <a:ext cx="547200" cy="342000"/>
+            <a:off x="28397887" y="16920000"/>
+            <a:ext cx="564480" cy="357120"/>
           </a:xfrm>
           <a:prstGeom prst="roundRect">
             <a:avLst>
@@ -4878,7 +4878,7 @@
               </a:spcAft>
             </a:pPr>
             <a:r>
-              <a:rPr sz="1500" b="1" i="0">
+              <a:rPr sz="1600" b="1" i="0">
                 <a:solidFill>
                   <a:srgbClr val="FFFFFF"/>
                 </a:solidFill>
@@ -4899,8 +4899,8 @@
         </p:nvSpPr>
         <p:spPr>
           <a:xfrm>
-            <a:off x="15552000" y="21150000"/>
-            <a:ext cx="13787999" cy="3438000"/>
+            <a:off x="15552000" y="22788000"/>
+            <a:ext cx="13787999" cy="2447999"/>
           </a:xfrm>
           <a:prstGeom prst="rect">
             <a:avLst/>
@@ -5004,8 +5004,8 @@
         </p:nvSpPr>
         <p:spPr>
           <a:xfrm>
-            <a:off x="15336000" y="25074000"/>
-            <a:ext cx="14220000" cy="8856000"/>
+            <a:off x="15336000" y="25721999"/>
+            <a:ext cx="14220000" cy="8208000"/>
           </a:xfrm>
           <a:prstGeom prst="roundRect">
             <a:avLst>
@@ -5037,7 +5037,7 @@
         </p:nvSpPr>
         <p:spPr>
           <a:xfrm>
-            <a:off x="15336000" y="25074000"/>
+            <a:off x="15336000" y="25721999"/>
             <a:ext cx="14220000" cy="720000"/>
           </a:xfrm>
           <a:prstGeom prst="round2SameRect">
@@ -5090,8 +5090,8 @@
         </p:nvSpPr>
         <p:spPr>
           <a:xfrm>
-            <a:off x="15552000" y="26010000"/>
-            <a:ext cx="6750000" cy="1655999"/>
+            <a:off x="15552000" y="26657999"/>
+            <a:ext cx="6750000" cy="1872000"/>
           </a:xfrm>
           <a:prstGeom prst="roundRect">
             <a:avLst>
@@ -5123,8 +5123,8 @@
         </p:nvSpPr>
         <p:spPr>
           <a:xfrm>
-            <a:off x="15624000" y="26045999"/>
-            <a:ext cx="6606000" cy="1583999"/>
+            <a:off x="15624000" y="26747999"/>
+            <a:ext cx="6606000" cy="1728000"/>
           </a:xfrm>
           <a:prstGeom prst="rect">
             <a:avLst/>
@@ -5149,7 +5149,7 @@
               </a:spcAft>
             </a:pPr>
             <a:r>
-              <a:rPr sz="5000" b="1" i="0">
+              <a:rPr sz="5600" b="1" i="0">
                 <a:solidFill>
                   <a:srgbClr val="1565C0"/>
                 </a:solidFill>
@@ -5173,7 +5173,7 @@
               </a:spcAft>
             </a:pPr>
             <a:r>
-              <a:rPr sz="2200" b="1" i="0">
+              <a:rPr sz="2400" b="1" i="0">
                 <a:solidFill>
                   <a:srgbClr val="0F172A"/>
                 </a:solidFill>
@@ -5194,8 +5194,8 @@
         </p:nvSpPr>
         <p:spPr>
           <a:xfrm>
-            <a:off x="22590000" y="26010000"/>
-            <a:ext cx="6750000" cy="1655999"/>
+            <a:off x="22590000" y="26657999"/>
+            <a:ext cx="6750000" cy="1872000"/>
           </a:xfrm>
           <a:prstGeom prst="roundRect">
             <a:avLst>
@@ -5227,8 +5227,8 @@
         </p:nvSpPr>
         <p:spPr>
           <a:xfrm>
-            <a:off x="22662000" y="26045999"/>
-            <a:ext cx="6606000" cy="1583999"/>
+            <a:off x="22662000" y="26747999"/>
+            <a:ext cx="6606000" cy="1728000"/>
           </a:xfrm>
           <a:prstGeom prst="rect">
             <a:avLst/>
@@ -5253,7 +5253,7 @@
               </a:spcAft>
             </a:pPr>
             <a:r>
-              <a:rPr sz="5000" b="1" i="0">
+              <a:rPr sz="5600" b="1" i="0">
                 <a:solidFill>
                   <a:srgbClr val="166534"/>
                 </a:solidFill>
@@ -5277,7 +5277,7 @@
               </a:spcAft>
             </a:pPr>
             <a:r>
-              <a:rPr sz="2200" b="1" i="0">
+              <a:rPr sz="2400" b="1" i="0">
                 <a:solidFill>
                   <a:srgbClr val="0F172A"/>
                 </a:solidFill>
@@ -5298,8 +5298,8 @@
         </p:nvSpPr>
         <p:spPr>
           <a:xfrm>
-            <a:off x="15552000" y="27810000"/>
-            <a:ext cx="6750000" cy="1655999"/>
+            <a:off x="15552000" y="28673999"/>
+            <a:ext cx="6750000" cy="1872000"/>
           </a:xfrm>
           <a:prstGeom prst="roundRect">
             <a:avLst>
@@ -5331,8 +5331,8 @@
         </p:nvSpPr>
         <p:spPr>
           <a:xfrm>
-            <a:off x="15624000" y="27845999"/>
-            <a:ext cx="6606000" cy="1583999"/>
+            <a:off x="15624000" y="28763999"/>
+            <a:ext cx="6606000" cy="1728000"/>
           </a:xfrm>
           <a:prstGeom prst="rect">
             <a:avLst/>
@@ -5357,7 +5357,7 @@
               </a:spcAft>
             </a:pPr>
             <a:r>
-              <a:rPr sz="5000" b="1" i="0">
+              <a:rPr sz="5600" b="1" i="0">
                 <a:solidFill>
                   <a:srgbClr val="0B2545"/>
                 </a:solidFill>
@@ -5381,7 +5381,7 @@
               </a:spcAft>
             </a:pPr>
             <a:r>
-              <a:rPr sz="2200" b="1" i="0">
+              <a:rPr sz="2400" b="1" i="0">
                 <a:solidFill>
                   <a:srgbClr val="0F172A"/>
                 </a:solidFill>
@@ -5402,8 +5402,8 @@
         </p:nvSpPr>
         <p:spPr>
           <a:xfrm>
-            <a:off x="22590000" y="27810000"/>
-            <a:ext cx="6750000" cy="1655999"/>
+            <a:off x="22590000" y="28673999"/>
+            <a:ext cx="6750000" cy="1872000"/>
           </a:xfrm>
           <a:prstGeom prst="roundRect">
             <a:avLst>
@@ -5435,8 +5435,8 @@
         </p:nvSpPr>
         <p:spPr>
           <a:xfrm>
-            <a:off x="22662000" y="27845999"/>
-            <a:ext cx="6606000" cy="1583999"/>
+            <a:off x="22662000" y="28763999"/>
+            <a:ext cx="6606000" cy="1728000"/>
           </a:xfrm>
           <a:prstGeom prst="rect">
             <a:avLst/>
@@ -5461,7 +5461,7 @@
               </a:spcAft>
             </a:pPr>
             <a:r>
-              <a:rPr sz="5000" b="1" i="0">
+              <a:rPr sz="5600" b="1" i="0">
                 <a:solidFill>
                   <a:srgbClr val="F59E0B"/>
                 </a:solidFill>
@@ -5485,7 +5485,7 @@
               </a:spcAft>
             </a:pPr>
             <a:r>
-              <a:rPr sz="2200" b="1" i="0">
+              <a:rPr sz="2400" b="1" i="0">
                 <a:solidFill>
                   <a:srgbClr val="0F172A"/>
                 </a:solidFill>
@@ -5506,8 +5506,8 @@
         </p:nvSpPr>
         <p:spPr>
           <a:xfrm>
-            <a:off x="15552000" y="29682000"/>
-            <a:ext cx="13787999" cy="4032000"/>
+            <a:off x="15552000" y="30761999"/>
+            <a:ext cx="13787999" cy="2952000"/>
           </a:xfrm>
           <a:prstGeom prst="rect">
             <a:avLst/>
@@ -5611,7 +5611,7 @@
         </p:nvSpPr>
         <p:spPr>
           <a:xfrm>
-            <a:off x="15336000" y="34200000"/>
+            <a:off x="15336000" y="34199999"/>
             <a:ext cx="14220000" cy="5040000"/>
           </a:xfrm>
           <a:prstGeom prst="roundRect">
@@ -5644,7 +5644,7 @@
         </p:nvSpPr>
         <p:spPr>
           <a:xfrm>
-            <a:off x="15336000" y="34200000"/>
+            <a:off x="15336000" y="34199999"/>
             <a:ext cx="14220000" cy="720000"/>
           </a:xfrm>
           <a:prstGeom prst="round2SameRect">
@@ -5697,7 +5697,7 @@
         </p:nvSpPr>
         <p:spPr>
           <a:xfrm>
-            <a:off x="15552000" y="35136000"/>
+            <a:off x="15552000" y="35135999"/>
             <a:ext cx="13787999" cy="3888000"/>
           </a:xfrm>
           <a:prstGeom prst="rect">

</xml_diff>

<commit_message>
Update ICCAS 2026 poster (remove acknowledgement, rebalance layout, finalize PPTX and PDF)
</commit_message>
<xml_diff>
--- a/ICCAS/poster/ICCAS2026_Poster_Quadruped.pptx
+++ b/ICCAS/poster/ICCAS2026_Poster_Quadruped.pptx
@@ -243,7 +243,7 @@
           <a:p>
             <a:fld id="{BFE96405-FC94-4A51-AF54-A6A424E5C0BA}" type="datetimeFigureOut">
               <a:rPr lang="ko-KR" altLang="en-US" smtClean="0"/>
-              <a:t>2026-01-06</a:t>
+              <a:t>2026-10-25</a:t>
             </a:fld>
             <a:endParaRPr lang="ko-KR" altLang="en-US"/>
           </a:p>
@@ -413,7 +413,7 @@
           <a:p>
             <a:fld id="{BFE96405-FC94-4A51-AF54-A6A424E5C0BA}" type="datetimeFigureOut">
               <a:rPr lang="ko-KR" altLang="en-US" smtClean="0"/>
-              <a:t>2026-01-06</a:t>
+              <a:t>2026-10-25</a:t>
             </a:fld>
             <a:endParaRPr lang="ko-KR" altLang="en-US"/>
           </a:p>
@@ -593,7 +593,7 @@
           <a:p>
             <a:fld id="{BFE96405-FC94-4A51-AF54-A6A424E5C0BA}" type="datetimeFigureOut">
               <a:rPr lang="ko-KR" altLang="en-US" smtClean="0"/>
-              <a:t>2026-01-06</a:t>
+              <a:t>2026-10-25</a:t>
             </a:fld>
             <a:endParaRPr lang="ko-KR" altLang="en-US"/>
           </a:p>
@@ -763,7 +763,7 @@
           <a:p>
             <a:fld id="{BFE96405-FC94-4A51-AF54-A6A424E5C0BA}" type="datetimeFigureOut">
               <a:rPr lang="ko-KR" altLang="en-US" smtClean="0"/>
-              <a:t>2026-01-06</a:t>
+              <a:t>2026-10-25</a:t>
             </a:fld>
             <a:endParaRPr lang="ko-KR" altLang="en-US"/>
           </a:p>
@@ -1007,7 +1007,7 @@
           <a:p>
             <a:fld id="{BFE96405-FC94-4A51-AF54-A6A424E5C0BA}" type="datetimeFigureOut">
               <a:rPr lang="ko-KR" altLang="en-US" smtClean="0"/>
-              <a:t>2026-01-06</a:t>
+              <a:t>2026-10-25</a:t>
             </a:fld>
             <a:endParaRPr lang="ko-KR" altLang="en-US"/>
           </a:p>
@@ -1239,7 +1239,7 @@
           <a:p>
             <a:fld id="{BFE96405-FC94-4A51-AF54-A6A424E5C0BA}" type="datetimeFigureOut">
               <a:rPr lang="ko-KR" altLang="en-US" smtClean="0"/>
-              <a:t>2026-01-06</a:t>
+              <a:t>2026-10-25</a:t>
             </a:fld>
             <a:endParaRPr lang="ko-KR" altLang="en-US"/>
           </a:p>
@@ -1606,7 +1606,7 @@
           <a:p>
             <a:fld id="{BFE96405-FC94-4A51-AF54-A6A424E5C0BA}" type="datetimeFigureOut">
               <a:rPr lang="ko-KR" altLang="en-US" smtClean="0"/>
-              <a:t>2026-01-06</a:t>
+              <a:t>2026-10-25</a:t>
             </a:fld>
             <a:endParaRPr lang="ko-KR" altLang="en-US"/>
           </a:p>
@@ -1724,7 +1724,7 @@
           <a:p>
             <a:fld id="{BFE96405-FC94-4A51-AF54-A6A424E5C0BA}" type="datetimeFigureOut">
               <a:rPr lang="ko-KR" altLang="en-US" smtClean="0"/>
-              <a:t>2026-01-06</a:t>
+              <a:t>2026-10-25</a:t>
             </a:fld>
             <a:endParaRPr lang="ko-KR" altLang="en-US"/>
           </a:p>
@@ -1819,7 +1819,7 @@
           <a:p>
             <a:fld id="{BFE96405-FC94-4A51-AF54-A6A424E5C0BA}" type="datetimeFigureOut">
               <a:rPr lang="ko-KR" altLang="en-US" smtClean="0"/>
-              <a:t>2026-01-06</a:t>
+              <a:t>2026-10-25</a:t>
             </a:fld>
             <a:endParaRPr lang="ko-KR" altLang="en-US"/>
           </a:p>
@@ -2096,7 +2096,7 @@
           <a:p>
             <a:fld id="{BFE96405-FC94-4A51-AF54-A6A424E5C0BA}" type="datetimeFigureOut">
               <a:rPr lang="ko-KR" altLang="en-US" smtClean="0"/>
-              <a:t>2026-01-06</a:t>
+              <a:t>2026-10-25</a:t>
             </a:fld>
             <a:endParaRPr lang="ko-KR" altLang="en-US"/>
           </a:p>
@@ -2353,7 +2353,7 @@
           <a:p>
             <a:fld id="{BFE96405-FC94-4A51-AF54-A6A424E5C0BA}" type="datetimeFigureOut">
               <a:rPr lang="ko-KR" altLang="en-US" smtClean="0"/>
-              <a:t>2026-01-06</a:t>
+              <a:t>2026-10-25</a:t>
             </a:fld>
             <a:endParaRPr lang="ko-KR" altLang="en-US"/>
           </a:p>
@@ -2566,7 +2566,7 @@
           <a:p>
             <a:fld id="{BFE96405-FC94-4A51-AF54-A6A424E5C0BA}" type="datetimeFigureOut">
               <a:rPr lang="ko-KR" altLang="en-US" smtClean="0"/>
-              <a:t>2026-01-06</a:t>
+              <a:t>2026-10-25</a:t>
             </a:fld>
             <a:endParaRPr lang="ko-KR" altLang="en-US"/>
           </a:p>
@@ -2973,459 +2973,14 @@
       </p:grpSpPr>
       <p:sp>
         <p:nvSpPr>
-          <p:cNvPr id="2" name="Rectangle 1"/>
-          <p:cNvSpPr/>
-          <p:nvPr/>
-        </p:nvSpPr>
-        <p:spPr>
-          <a:xfrm>
-            <a:off x="0" y="0"/>
-            <a:ext cx="30275999" cy="4140000"/>
-          </a:xfrm>
-          <a:prstGeom prst="rect">
-            <a:avLst/>
-          </a:prstGeom>
-          <a:gradFill rotWithShape="1">
-            <a:gsLst>
-              <a:gs pos="0">
-                <a:srgbClr val="071A33"/>
-              </a:gs>
-              <a:gs pos="100000">
-                <a:srgbClr val="1565C0"/>
-              </a:gs>
-            </a:gsLst>
-            <a:lin scaled="0" ang="0"/>
-          </a:gradFill>
-          <a:ln>
-            <a:noFill/>
-          </a:ln>
-        </p:spPr>
-        <p:txBody>
-          <a:bodyPr rtlCol="0" anchor="ctr"/>
-          <a:lstStyle/>
-          <a:p>
-            <a:pPr algn="ctr"/>
-          </a:p>
-        </p:txBody>
-      </p:sp>
-      <p:sp>
-        <p:nvSpPr>
-          <p:cNvPr id="3" name="Rectangle 2"/>
-          <p:cNvSpPr/>
-          <p:nvPr/>
-        </p:nvSpPr>
-        <p:spPr>
-          <a:xfrm>
-            <a:off x="0" y="0"/>
-            <a:ext cx="30275999" cy="468000"/>
-          </a:xfrm>
-          <a:prstGeom prst="rect">
-            <a:avLst/>
-          </a:prstGeom>
-          <a:solidFill>
-            <a:srgbClr val="071A33"/>
-          </a:solidFill>
-          <a:ln>
-            <a:noFill/>
-          </a:ln>
-        </p:spPr>
-        <p:txBody>
-          <a:bodyPr rtlCol="0" anchor="ctr"/>
-          <a:lstStyle/>
-          <a:p>
-            <a:pPr algn="ctr"/>
-          </a:p>
-        </p:txBody>
-      </p:sp>
-      <p:sp>
-        <p:nvSpPr>
-          <p:cNvPr id="4" name="Rounded Rectangle 3"/>
-          <p:cNvSpPr/>
-          <p:nvPr/>
-        </p:nvSpPr>
-        <p:spPr>
-          <a:xfrm>
-            <a:off x="720000" y="79200"/>
-            <a:ext cx="9411840" cy="478080"/>
-          </a:xfrm>
-          <a:prstGeom prst="roundRect">
-            <a:avLst>
-              <a:gd name="adj" fmla="val 40000"/>
-            </a:avLst>
-          </a:prstGeom>
-          <a:solidFill>
-            <a:srgbClr val="F59E0B"/>
-          </a:solidFill>
-          <a:ln>
-            <a:noFill/>
-          </a:ln>
-        </p:spPr>
-        <p:txBody>
-          <a:bodyPr rtlCol="0" anchor="ctr" wrap="none" lIns="0" rIns="0" tIns="0" bIns="0"/>
-          <a:lstStyle/>
-          <a:p>
-            <a:pPr algn="ctr">
-              <a:lnSpc>
-                <a:spcPct val="105000"/>
-              </a:lnSpc>
-              <a:spcBef>
-                <a:spcPts val="0"/>
-              </a:spcBef>
-              <a:spcAft>
-                <a:spcPts val="0"/>
-              </a:spcAft>
-            </a:pPr>
-            <a:r>
-              <a:rPr sz="2400" b="1" i="0">
-                <a:solidFill>
-                  <a:srgbClr val="071A33"/>
-                </a:solidFill>
-                <a:latin typeface="Arial"/>
-                <a:ea typeface="Arial"/>
-                <a:cs typeface="Arial"/>
-              </a:rPr>
-              <a:t>ICCAS 2026 Poster  [ Session Code [TuP...] ]</a:t>
-            </a:r>
-          </a:p>
-        </p:txBody>
-      </p:sp>
-      <p:sp>
-        <p:nvSpPr>
-          <p:cNvPr id="5" name="TextBox 4"/>
-          <p:cNvSpPr txBox="1"/>
-          <p:nvPr/>
-        </p:nvSpPr>
-        <p:spPr>
-          <a:xfrm>
-            <a:off x="13320000" y="79200"/>
-            <a:ext cx="16235999" cy="324000"/>
-          </a:xfrm>
-          <a:prstGeom prst="rect">
-            <a:avLst/>
-          </a:prstGeom>
-          <a:noFill/>
-        </p:spPr>
-        <p:txBody>
-          <a:bodyPr wrap="square" anchor="t" lIns="0" rIns="0" tIns="0" bIns="0">
-            <a:noAutofit/>
-          </a:bodyPr>
-          <a:lstStyle/>
-          <a:p>
-            <a:pPr algn="r">
-              <a:lnSpc>
-                <a:spcPct val="105000"/>
-              </a:lnSpc>
-              <a:spcBef>
-                <a:spcPts val="0"/>
-              </a:spcBef>
-              <a:spcAft>
-                <a:spcPts val="400"/>
-              </a:spcAft>
-            </a:pPr>
-            <a:r>
-              <a:rPr sz="2500" b="1" i="0">
-                <a:solidFill>
-                  <a:srgbClr val="BFDBFE"/>
-                </a:solidFill>
-                <a:latin typeface="Arial"/>
-                <a:ea typeface="Arial"/>
-                <a:cs typeface="Arial"/>
-              </a:rPr>
-              <a:t>Computer Graphics and Vision Lab (CGV)  ·  Handong Global University</a:t>
-            </a:r>
-          </a:p>
-        </p:txBody>
-      </p:sp>
-      <p:sp>
-        <p:nvSpPr>
-          <p:cNvPr id="6" name="TextBox 5"/>
-          <p:cNvSpPr txBox="1"/>
-          <p:nvPr/>
-        </p:nvSpPr>
-        <p:spPr>
-          <a:xfrm>
-            <a:off x="720000" y="576000"/>
-            <a:ext cx="28835999" cy="2088000"/>
-          </a:xfrm>
-          <a:prstGeom prst="rect">
-            <a:avLst/>
-          </a:prstGeom>
-          <a:noFill/>
-        </p:spPr>
-        <p:txBody>
-          <a:bodyPr wrap="square" anchor="t" lIns="0" rIns="0" tIns="0" bIns="0">
-            <a:noAutofit/>
-          </a:bodyPr>
-          <a:lstStyle/>
-          <a:p>
-            <a:pPr algn="ctr">
-              <a:lnSpc>
-                <a:spcPct val="105000"/>
-              </a:lnSpc>
-              <a:spcBef>
-                <a:spcPts val="0"/>
-              </a:spcBef>
-              <a:spcAft>
-                <a:spcPts val="400"/>
-              </a:spcAft>
-            </a:pPr>
-            <a:r>
-              <a:rPr sz="6400" b="1" i="0">
-                <a:solidFill>
-                  <a:srgbClr val="FFFFFF"/>
-                </a:solidFill>
-                <a:latin typeface="Arial"/>
-                <a:ea typeface="Arial"/>
-                <a:cs typeface="Arial"/>
-              </a:rPr>
-              <a:t>Bridging the Sim-to-Real Gap in Quadrupedal Visual Navigation via 3D Gaussian Splatting</a:t>
-            </a:r>
-          </a:p>
-        </p:txBody>
-      </p:sp>
-      <p:sp>
-        <p:nvSpPr>
-          <p:cNvPr id="7" name="TextBox 6"/>
-          <p:cNvSpPr txBox="1"/>
-          <p:nvPr/>
-        </p:nvSpPr>
-        <p:spPr>
-          <a:xfrm>
-            <a:off x="720000" y="2736000"/>
-            <a:ext cx="28835999" cy="576000"/>
-          </a:xfrm>
-          <a:prstGeom prst="rect">
-            <a:avLst/>
-          </a:prstGeom>
-          <a:noFill/>
-        </p:spPr>
-        <p:txBody>
-          <a:bodyPr wrap="square" anchor="t" lIns="0" rIns="0" tIns="0" bIns="0">
-            <a:noAutofit/>
-          </a:bodyPr>
-          <a:lstStyle/>
-          <a:p>
-            <a:pPr algn="ctr">
-              <a:lnSpc>
-                <a:spcPct val="105000"/>
-              </a:lnSpc>
-              <a:spcBef>
-                <a:spcPts val="0"/>
-              </a:spcBef>
-              <a:spcAft>
-                <a:spcPts val="100"/>
-              </a:spcAft>
-            </a:pPr>
-            <a:r>
-              <a:rPr sz="3800" b="1" i="0">
-                <a:solidFill>
-                  <a:srgbClr val="FFFFFF"/>
-                </a:solidFill>
-                <a:latin typeface="Arial"/>
-                <a:ea typeface="Arial"/>
-                <a:cs typeface="Arial"/>
-              </a:rPr>
-              <a:t>Minseok Lee</a:t>
-            </a:r>
-            <a:r>
-              <a:rPr sz="3800" b="1" i="0" baseline="30000">
-                <a:solidFill>
-                  <a:srgbClr val="FFFFFF"/>
-                </a:solidFill>
-                <a:latin typeface="Arial"/>
-                <a:ea typeface="Arial"/>
-                <a:cs typeface="Arial"/>
-              </a:rPr>
-              <a:t>1</a:t>
-            </a:r>
-            <a:r>
-              <a:rPr sz="3800" b="1" i="0">
-                <a:solidFill>
-                  <a:srgbClr val="FFFFFF"/>
-                </a:solidFill>
-                <a:latin typeface="Arial"/>
-                <a:ea typeface="Arial"/>
-                <a:cs typeface="Arial"/>
-              </a:rPr>
-              <a:t>,  Seongyu Han</a:t>
-            </a:r>
-            <a:r>
-              <a:rPr sz="3800" b="1" i="0" baseline="30000">
-                <a:solidFill>
-                  <a:srgbClr val="FFFFFF"/>
-                </a:solidFill>
-                <a:latin typeface="Arial"/>
-                <a:ea typeface="Arial"/>
-                <a:cs typeface="Arial"/>
-              </a:rPr>
-              <a:t>1</a:t>
-            </a:r>
-            <a:r>
-              <a:rPr sz="3800" b="1" i="0">
-                <a:solidFill>
-                  <a:srgbClr val="FFFFFF"/>
-                </a:solidFill>
-                <a:latin typeface="Arial"/>
-                <a:ea typeface="Arial"/>
-                <a:cs typeface="Arial"/>
-              </a:rPr>
-              <a:t>,  Heejae Moon</a:t>
-            </a:r>
-            <a:r>
-              <a:rPr sz="3800" b="1" i="0" baseline="30000">
-                <a:solidFill>
-                  <a:srgbClr val="FFFFFF"/>
-                </a:solidFill>
-                <a:latin typeface="Arial"/>
-                <a:ea typeface="Arial"/>
-                <a:cs typeface="Arial"/>
-              </a:rPr>
-              <a:t>1</a:t>
-            </a:r>
-            <a:r>
-              <a:rPr sz="3800" b="1" i="0">
-                <a:solidFill>
-                  <a:srgbClr val="FFFFFF"/>
-                </a:solidFill>
-                <a:latin typeface="Arial"/>
-                <a:ea typeface="Arial"/>
-                <a:cs typeface="Arial"/>
-              </a:rPr>
-              <a:t>,  and  Sung Soo Hwang</a:t>
-            </a:r>
-            <a:r>
-              <a:rPr sz="3800" b="1" i="0" baseline="30000">
-                <a:solidFill>
-                  <a:srgbClr val="FFFFFF"/>
-                </a:solidFill>
-                <a:latin typeface="Arial"/>
-                <a:ea typeface="Arial"/>
-                <a:cs typeface="Arial"/>
-              </a:rPr>
-              <a:t>1*</a:t>
-            </a:r>
-          </a:p>
-        </p:txBody>
-      </p:sp>
-      <p:sp>
-        <p:nvSpPr>
-          <p:cNvPr id="8" name="TextBox 7"/>
-          <p:cNvSpPr txBox="1"/>
-          <p:nvPr/>
-        </p:nvSpPr>
-        <p:spPr>
-          <a:xfrm>
-            <a:off x="720000" y="3384000"/>
-            <a:ext cx="28835999" cy="432000"/>
-          </a:xfrm>
-          <a:prstGeom prst="rect">
-            <a:avLst/>
-          </a:prstGeom>
-          <a:noFill/>
-        </p:spPr>
-        <p:txBody>
-          <a:bodyPr wrap="square" anchor="t" lIns="0" rIns="0" tIns="0" bIns="0">
-            <a:noAutofit/>
-          </a:bodyPr>
-          <a:lstStyle/>
-          <a:p>
-            <a:pPr algn="ctr">
-              <a:lnSpc>
-                <a:spcPct val="105000"/>
-              </a:lnSpc>
-              <a:spcBef>
-                <a:spcPts val="0"/>
-              </a:spcBef>
-              <a:spcAft>
-                <a:spcPts val="0"/>
-              </a:spcAft>
-            </a:pPr>
-            <a:r>
-              <a:rPr sz="2400" b="0" i="0" baseline="30000">
-                <a:solidFill>
-                  <a:srgbClr val="BFDBFE"/>
-                </a:solidFill>
-                <a:latin typeface="Arial"/>
-                <a:ea typeface="Arial"/>
-                <a:cs typeface="Arial"/>
-              </a:rPr>
-              <a:t>1</a:t>
-            </a:r>
-            <a:r>
-              <a:rPr sz="2400" b="0" i="0">
-                <a:solidFill>
-                  <a:srgbClr val="BFDBFE"/>
-                </a:solidFill>
-                <a:latin typeface="Arial"/>
-                <a:ea typeface="Arial"/>
-                <a:cs typeface="Arial"/>
-              </a:rPr>
-              <a:t>School of Artificial Intelligence, Computer and Electrical Engineering, Handong Global University, Pohang 37554, Korea   ·   </a:t>
-            </a:r>
-            <a:r>
-              <a:rPr sz="2400" b="0" i="0" baseline="30000">
-                <a:solidFill>
-                  <a:srgbClr val="BFDBFE"/>
-                </a:solidFill>
-                <a:latin typeface="Arial"/>
-                <a:ea typeface="Arial"/>
-                <a:cs typeface="Arial"/>
-              </a:rPr>
-              <a:t>*</a:t>
-            </a:r>
-            <a:r>
-              <a:rPr sz="2400" b="0" i="0">
-                <a:solidFill>
-                  <a:srgbClr val="BFDBFE"/>
-                </a:solidFill>
-                <a:latin typeface="Arial"/>
-                <a:ea typeface="Arial"/>
-                <a:cs typeface="Arial"/>
-              </a:rPr>
-              <a:t>sshwang@handong.edu</a:t>
-            </a:r>
-          </a:p>
-        </p:txBody>
-      </p:sp>
-      <p:sp>
-        <p:nvSpPr>
-          <p:cNvPr id="9" name="Rectangle 8"/>
-          <p:cNvSpPr/>
-          <p:nvPr/>
-        </p:nvSpPr>
-        <p:spPr>
-          <a:xfrm>
-            <a:off x="0" y="4140000"/>
-            <a:ext cx="30275999" cy="125999"/>
-          </a:xfrm>
-          <a:prstGeom prst="rect">
-            <a:avLst/>
-          </a:prstGeom>
-          <a:solidFill>
-            <a:srgbClr val="F59E0B"/>
-          </a:solidFill>
-          <a:ln>
-            <a:noFill/>
-          </a:ln>
-        </p:spPr>
-        <p:txBody>
-          <a:bodyPr rtlCol="0" anchor="ctr"/>
-          <a:lstStyle/>
-          <a:p>
-            <a:pPr algn="ctr"/>
-          </a:p>
-        </p:txBody>
-      </p:sp>
-      <p:sp>
-        <p:nvSpPr>
           <p:cNvPr id="10" name="Rounded Rectangle 9"/>
           <p:cNvSpPr/>
           <p:nvPr/>
         </p:nvSpPr>
         <p:spPr>
           <a:xfrm>
-            <a:off x="720000" y="4428000"/>
-            <a:ext cx="28835999" cy="11232000"/>
+            <a:off x="720000" y="4716000"/>
+            <a:ext cx="28835999" cy="11340000"/>
           </a:xfrm>
           <a:prstGeom prst="roundRect">
             <a:avLst>
@@ -3446,6 +3001,7 @@
           <a:lstStyle/>
           <a:p>
             <a:pPr algn="ctr"/>
+            <a:endParaRPr/>
           </a:p>
         </p:txBody>
       </p:sp>
@@ -3457,7 +3013,7 @@
         </p:nvSpPr>
         <p:spPr>
           <a:xfrm>
-            <a:off x="720000" y="4428000"/>
+            <a:off x="720000" y="4716000"/>
             <a:ext cx="28835999" cy="720000"/>
           </a:xfrm>
           <a:prstGeom prst="round2SameRect">
@@ -3474,7 +3030,7 @@
           </a:ln>
         </p:spPr>
         <p:txBody>
-          <a:bodyPr rtlCol="0" anchor="ctr" wrap="none" lIns="288000" rIns="288000" tIns="0" bIns="0"/>
+          <a:bodyPr wrap="none" lIns="288000" tIns="0" rIns="288000" bIns="0" rtlCol="0" anchor="ctr"/>
           <a:lstStyle/>
           <a:p>
             <a:pPr algn="l">
@@ -3518,7 +3074,7 @@
         </p:blipFill>
         <p:spPr>
           <a:xfrm>
-            <a:off x="1727999" y="5400000"/>
+            <a:off x="1727999" y="5706000"/>
             <a:ext cx="26820000" cy="9627741"/>
           </a:xfrm>
           <a:prstGeom prst="rect">
@@ -3534,8 +3090,8 @@
         </p:nvSpPr>
         <p:spPr>
           <a:xfrm>
-            <a:off x="936000" y="15081741"/>
-            <a:ext cx="28403999" cy="360000"/>
+            <a:off x="936000" y="15444000"/>
+            <a:ext cx="28403999" cy="378000"/>
           </a:xfrm>
           <a:prstGeom prst="rect">
             <a:avLst/>
@@ -3543,7 +3099,7 @@
           <a:noFill/>
         </p:spPr>
         <p:txBody>
-          <a:bodyPr wrap="square" anchor="t" lIns="0" rIns="0" tIns="0" bIns="0">
+          <a:bodyPr wrap="square" lIns="0" tIns="0" rIns="0" bIns="0" anchor="t">
             <a:noAutofit/>
           </a:bodyPr>
           <a:lstStyle/>
@@ -3592,8 +3148,8 @@
         </p:nvSpPr>
         <p:spPr>
           <a:xfrm>
-            <a:off x="720000" y="15947999"/>
-            <a:ext cx="14220000" cy="5040000"/>
+            <a:off x="720000" y="16416000"/>
+            <a:ext cx="14220000" cy="5220000"/>
           </a:xfrm>
           <a:prstGeom prst="roundRect">
             <a:avLst>
@@ -3614,6 +3170,7 @@
           <a:lstStyle/>
           <a:p>
             <a:pPr algn="ctr"/>
+            <a:endParaRPr/>
           </a:p>
         </p:txBody>
       </p:sp>
@@ -3625,7 +3182,7 @@
         </p:nvSpPr>
         <p:spPr>
           <a:xfrm>
-            <a:off x="720000" y="15947999"/>
+            <a:off x="720000" y="16416000"/>
             <a:ext cx="14220000" cy="720000"/>
           </a:xfrm>
           <a:prstGeom prst="round2SameRect">
@@ -3642,7 +3199,7 @@
           </a:ln>
         </p:spPr>
         <p:txBody>
-          <a:bodyPr rtlCol="0" anchor="ctr" wrap="none" lIns="288000" rIns="288000" tIns="0" bIns="0"/>
+          <a:bodyPr wrap="none" lIns="288000" tIns="0" rIns="288000" bIns="0" rtlCol="0" anchor="ctr"/>
           <a:lstStyle/>
           <a:p>
             <a:pPr algn="l">
@@ -3678,8 +3235,8 @@
         </p:nvSpPr>
         <p:spPr>
           <a:xfrm>
-            <a:off x="936000" y="16884000"/>
-            <a:ext cx="13787999" cy="3888000"/>
+            <a:off x="936000" y="17388000"/>
+            <a:ext cx="13787999" cy="4031999"/>
           </a:xfrm>
           <a:prstGeom prst="rect">
             <a:avLst/>
@@ -3687,12 +3244,12 @@
           <a:noFill/>
         </p:spPr>
         <p:txBody>
-          <a:bodyPr wrap="square" anchor="t" lIns="0" rIns="0" tIns="0" bIns="0">
+          <a:bodyPr wrap="square" lIns="0" tIns="0" rIns="0" bIns="0" anchor="t">
             <a:noAutofit/>
           </a:bodyPr>
           <a:lstStyle/>
           <a:p>
-            <a:pPr algn="l" marL="288000" indent="-288000">
+            <a:pPr marL="288000" indent="-288000" algn="l">
               <a:lnSpc>
                 <a:spcPct val="105000"/>
               </a:lnSpc>
@@ -3700,7 +3257,7 @@
                 <a:spcPts val="0"/>
               </a:spcBef>
               <a:spcAft>
-                <a:spcPts val="300"/>
+                <a:spcPts val="500"/>
               </a:spcAft>
               <a:buClr>
                 <a:srgbClr val="334155"/>
@@ -3733,7 +3290,7 @@
             </a:r>
           </a:p>
           <a:p>
-            <a:pPr algn="l" marL="288000" indent="-288000">
+            <a:pPr marL="288000" indent="-288000" algn="l">
               <a:lnSpc>
                 <a:spcPct val="105000"/>
               </a:lnSpc>
@@ -3741,7 +3298,7 @@
                 <a:spcPts val="0"/>
               </a:spcBef>
               <a:spcAft>
-                <a:spcPts val="300"/>
+                <a:spcPts val="500"/>
               </a:spcAft>
               <a:buClr>
                 <a:srgbClr val="334155"/>
@@ -3774,7 +3331,7 @@
             </a:r>
           </a:p>
           <a:p>
-            <a:pPr algn="l" marL="288000" indent="-288000">
+            <a:pPr marL="288000" indent="-288000" algn="l">
               <a:lnSpc>
                 <a:spcPct val="105000"/>
               </a:lnSpc>
@@ -3782,7 +3339,7 @@
                 <a:spcPts val="0"/>
               </a:spcBef>
               <a:spcAft>
-                <a:spcPts val="300"/>
+                <a:spcPts val="500"/>
               </a:spcAft>
               <a:buClr>
                 <a:srgbClr val="334155"/>
@@ -3815,7 +3372,7 @@
             </a:r>
           </a:p>
           <a:p>
-            <a:pPr algn="l" marL="288000" indent="-288000">
+            <a:pPr marL="288000" indent="-288000" algn="l">
               <a:lnSpc>
                 <a:spcPct val="105000"/>
               </a:lnSpc>
@@ -3865,8 +3422,8 @@
         </p:nvSpPr>
         <p:spPr>
           <a:xfrm>
-            <a:off x="720000" y="21258000"/>
-            <a:ext cx="14220000" cy="8856000"/>
+            <a:off x="720000" y="21996000"/>
+            <a:ext cx="14220000" cy="9432000"/>
           </a:xfrm>
           <a:prstGeom prst="roundRect">
             <a:avLst>
@@ -3887,6 +3444,7 @@
           <a:lstStyle/>
           <a:p>
             <a:pPr algn="ctr"/>
+            <a:endParaRPr/>
           </a:p>
         </p:txBody>
       </p:sp>
@@ -3898,7 +3456,7 @@
         </p:nvSpPr>
         <p:spPr>
           <a:xfrm>
-            <a:off x="720000" y="21258000"/>
+            <a:off x="720000" y="21996000"/>
             <a:ext cx="14220000" cy="720000"/>
           </a:xfrm>
           <a:prstGeom prst="round2SameRect">
@@ -3915,7 +3473,7 @@
           </a:ln>
         </p:spPr>
         <p:txBody>
-          <a:bodyPr rtlCol="0" anchor="ctr" wrap="none" lIns="288000" rIns="288000" tIns="0" bIns="0"/>
+          <a:bodyPr wrap="none" lIns="288000" tIns="0" rIns="288000" bIns="0" rtlCol="0" anchor="ctr"/>
           <a:lstStyle/>
           <a:p>
             <a:pPr algn="l">
@@ -3959,7 +3517,7 @@
         </p:blipFill>
         <p:spPr>
           <a:xfrm>
-            <a:off x="1259999" y="22194000"/>
+            <a:off x="1259999" y="22950000"/>
             <a:ext cx="13140000" cy="5010791"/>
           </a:xfrm>
           <a:prstGeom prst="rect">
@@ -3975,7 +3533,7 @@
         </p:nvSpPr>
         <p:spPr>
           <a:xfrm>
-            <a:off x="1385999" y="22284000"/>
+            <a:off x="1385999" y="23040000"/>
             <a:ext cx="3407040" cy="402480"/>
           </a:xfrm>
           <a:prstGeom prst="roundRect">
@@ -3991,7 +3549,7 @@
           </a:ln>
         </p:spPr>
         <p:txBody>
-          <a:bodyPr rtlCol="0" anchor="ctr" wrap="none" lIns="0" rIns="0" tIns="0" bIns="0"/>
+          <a:bodyPr wrap="none" lIns="0" tIns="0" rIns="0" bIns="0" rtlCol="0" anchor="ctr"/>
           <a:lstStyle/>
           <a:p>
             <a:pPr algn="ctr">
@@ -4027,7 +3585,7 @@
         </p:nvSpPr>
         <p:spPr>
           <a:xfrm>
-            <a:off x="7956000" y="22284000"/>
+            <a:off x="7956000" y="23040000"/>
             <a:ext cx="4556160" cy="402480"/>
           </a:xfrm>
           <a:prstGeom prst="roundRect">
@@ -4043,7 +3601,7 @@
           </a:ln>
         </p:spPr>
         <p:txBody>
-          <a:bodyPr rtlCol="0" anchor="ctr" wrap="none" lIns="0" rIns="0" tIns="0" bIns="0"/>
+          <a:bodyPr wrap="none" lIns="0" tIns="0" rIns="0" bIns="0" rtlCol="0" anchor="ctr"/>
           <a:lstStyle/>
           <a:p>
             <a:pPr algn="ctr">
@@ -4079,8 +3637,8 @@
         </p:nvSpPr>
         <p:spPr>
           <a:xfrm>
-            <a:off x="936000" y="27312791"/>
-            <a:ext cx="13787999" cy="2585208"/>
+            <a:off x="936000" y="28134000"/>
+            <a:ext cx="13787999" cy="3096000"/>
           </a:xfrm>
           <a:prstGeom prst="rect">
             <a:avLst/>
@@ -4088,12 +3646,12 @@
           <a:noFill/>
         </p:spPr>
         <p:txBody>
-          <a:bodyPr wrap="square" anchor="t" lIns="0" rIns="0" tIns="0" bIns="0">
+          <a:bodyPr wrap="square" lIns="0" tIns="0" rIns="0" bIns="0" anchor="t">
             <a:noAutofit/>
           </a:bodyPr>
           <a:lstStyle/>
           <a:p>
-            <a:pPr algn="l" marL="288000" indent="-288000">
+            <a:pPr marL="288000" indent="-288000" algn="l">
               <a:lnSpc>
                 <a:spcPct val="105000"/>
               </a:lnSpc>
@@ -4101,7 +3659,7 @@
                 <a:spcPts val="0"/>
               </a:spcBef>
               <a:spcAft>
-                <a:spcPts val="300"/>
+                <a:spcPts val="450"/>
               </a:spcAft>
               <a:buClr>
                 <a:srgbClr val="1565C0"/>
@@ -4111,7 +3669,7 @@
               <a:buChar char="■"/>
             </a:pPr>
             <a:r>
-              <a:rPr sz="2400" b="1" i="0">
+              <a:rPr sz="2500" b="1" i="0">
                 <a:solidFill>
                   <a:srgbClr val="0F172A"/>
                 </a:solidFill>
@@ -4122,7 +3680,7 @@
               <a:t>Offline Digital Twin Modeling:</a:t>
             </a:r>
             <a:r>
-              <a:rPr sz="2400" b="0" i="0">
+              <a:rPr sz="2500" b="0" i="0">
                 <a:solidFill>
                   <a:srgbClr val="0F172A"/>
                 </a:solidFill>
@@ -4134,7 +3692,7 @@
             </a:r>
           </a:p>
           <a:p>
-            <a:pPr algn="l" marL="288000" indent="-288000">
+            <a:pPr marL="288000" indent="-288000" algn="l">
               <a:lnSpc>
                 <a:spcPct val="105000"/>
               </a:lnSpc>
@@ -4142,7 +3700,7 @@
                 <a:spcPts val="0"/>
               </a:spcBef>
               <a:spcAft>
-                <a:spcPts val="300"/>
+                <a:spcPts val="450"/>
               </a:spcAft>
               <a:buClr>
                 <a:srgbClr val="1565C0"/>
@@ -4152,7 +3710,7 @@
               <a:buChar char="■"/>
             </a:pPr>
             <a:r>
-              <a:rPr sz="2400" b="1" i="0">
+              <a:rPr sz="2500" b="1" i="0">
                 <a:solidFill>
                   <a:srgbClr val="0F172A"/>
                 </a:solidFill>
@@ -4163,7 +3721,7 @@
               <a:t>NVIDIA fVDB Sparse Volumetric Mesh:</a:t>
             </a:r>
             <a:r>
-              <a:rPr sz="2400" b="0" i="0">
+              <a:rPr sz="2500" b="0" i="0">
                 <a:solidFill>
                   <a:srgbClr val="0F172A"/>
                 </a:solidFill>
@@ -4175,7 +3733,7 @@
             </a:r>
           </a:p>
           <a:p>
-            <a:pPr algn="l" marL="288000" indent="-288000">
+            <a:pPr marL="288000" indent="-288000" algn="l">
               <a:lnSpc>
                 <a:spcPct val="105000"/>
               </a:lnSpc>
@@ -4193,7 +3751,7 @@
               <a:buChar char="■"/>
             </a:pPr>
             <a:r>
-              <a:rPr sz="2400" b="1" i="0">
+              <a:rPr sz="2500" b="1" i="0">
                 <a:solidFill>
                   <a:srgbClr val="0F172A"/>
                 </a:solidFill>
@@ -4204,7 +3762,7 @@
               <a:t>Sensor Profile Alignment:</a:t>
             </a:r>
             <a:r>
-              <a:rPr sz="2400" b="0" i="0">
+              <a:rPr sz="2500" b="0" i="0">
                 <a:solidFill>
                   <a:srgbClr val="0F172A"/>
                 </a:solidFill>
@@ -4225,8 +3783,8 @@
         </p:nvSpPr>
         <p:spPr>
           <a:xfrm>
-            <a:off x="720000" y="30384000"/>
-            <a:ext cx="14220000" cy="8856000"/>
+            <a:off x="720000" y="31788000"/>
+            <a:ext cx="14220000" cy="8928000"/>
           </a:xfrm>
           <a:prstGeom prst="roundRect">
             <a:avLst>
@@ -4247,9 +3805,41 @@
           <a:lstStyle/>
           <a:p>
             <a:pPr algn="ctr"/>
-          </a:p>
-        </p:txBody>
-      </p:sp>
+            <a:endParaRPr/>
+          </a:p>
+        </p:txBody>
+      </p:sp>
+      <p:pic>
+        <p:nvPicPr>
+          <p:cNvPr id="57" name="Picture 24" descr="sim_nav2_crop.png">
+            <a:extLst>
+              <a:ext uri="{FF2B5EF4-FFF2-40B4-BE49-F238E27FC236}">
+                <a16:creationId xmlns:a16="http://schemas.microsoft.com/office/drawing/2014/main" id="{19DA1997-0E7D-EBB4-9DEB-DC0B74715FF4}"/>
+              </a:ext>
+            </a:extLst>
+          </p:cNvPr>
+          <p:cNvPicPr>
+            <a:picLocks noChangeAspect="1"/>
+          </p:cNvPicPr>
+          <p:nvPr/>
+        </p:nvPicPr>
+        <p:blipFill>
+          <a:blip r:embed="rId4"/>
+          <a:srcRect l="11593" r="49414" b="24610"/>
+          <a:stretch>
+            <a:fillRect/>
+          </a:stretch>
+        </p:blipFill>
+        <p:spPr>
+          <a:xfrm>
+            <a:off x="927601" y="32741999"/>
+            <a:ext cx="7179282" cy="4258217"/>
+          </a:xfrm>
+          <a:prstGeom prst="rect">
+            <a:avLst/>
+          </a:prstGeom>
+        </p:spPr>
+      </p:pic>
       <p:sp>
         <p:nvSpPr>
           <p:cNvPr id="24" name="Round Same Side Corner Rectangle 23"/>
@@ -4258,7 +3848,7 @@
         </p:nvSpPr>
         <p:spPr>
           <a:xfrm>
-            <a:off x="720000" y="30384000"/>
+            <a:off x="720000" y="31788000"/>
             <a:ext cx="14220000" cy="720000"/>
           </a:xfrm>
           <a:prstGeom prst="round2SameRect">
@@ -4275,7 +3865,7 @@
           </a:ln>
         </p:spPr>
         <p:txBody>
-          <a:bodyPr rtlCol="0" anchor="ctr" wrap="none" lIns="288000" rIns="288000" tIns="0" bIns="0"/>
+          <a:bodyPr wrap="none" lIns="288000" tIns="0" rIns="288000" bIns="0" rtlCol="0" anchor="ctr"/>
           <a:lstStyle/>
           <a:p>
             <a:pPr algn="l">
@@ -4313,14 +3903,15 @@
         </p:nvPicPr>
         <p:blipFill>
           <a:blip r:embed="rId4"/>
+          <a:srcRect l="53451"/>
           <a:stretch>
             <a:fillRect/>
           </a:stretch>
         </p:blipFill>
         <p:spPr>
           <a:xfrm>
-            <a:off x="936000" y="31320000"/>
-            <a:ext cx="13787999" cy="4258217"/>
+            <a:off x="8305800" y="32742000"/>
+            <a:ext cx="6418199" cy="4258217"/>
           </a:xfrm>
           <a:prstGeom prst="rect">
             <a:avLst/>
@@ -4335,7 +3926,7 @@
         </p:nvSpPr>
         <p:spPr>
           <a:xfrm>
-            <a:off x="1062000" y="31410000"/>
+            <a:off x="1062000" y="32832000"/>
             <a:ext cx="4392000" cy="402480"/>
           </a:xfrm>
           <a:prstGeom prst="roundRect">
@@ -4351,7 +3942,7 @@
           </a:ln>
         </p:spPr>
         <p:txBody>
-          <a:bodyPr rtlCol="0" anchor="ctr" wrap="none" lIns="0" rIns="0" tIns="0" bIns="0"/>
+          <a:bodyPr wrap="none" lIns="0" tIns="0" rIns="0" bIns="0" rtlCol="0" anchor="ctr"/>
           <a:lstStyle/>
           <a:p>
             <a:pPr algn="ctr">
@@ -4366,7 +3957,7 @@
               </a:spcAft>
             </a:pPr>
             <a:r>
-              <a:rPr sz="1900" b="1" i="0">
+              <a:rPr sz="1900" b="1" i="0" dirty="0">
                 <a:solidFill>
                   <a:srgbClr val="FFFFFF"/>
                 </a:solidFill>
@@ -4387,7 +3978,7 @@
         </p:nvSpPr>
         <p:spPr>
           <a:xfrm>
-            <a:off x="8457283" y="31410000"/>
+            <a:off x="8475283" y="32814030"/>
             <a:ext cx="5376960" cy="402480"/>
           </a:xfrm>
           <a:prstGeom prst="roundRect">
@@ -4403,7 +3994,7 @@
           </a:ln>
         </p:spPr>
         <p:txBody>
-          <a:bodyPr rtlCol="0" anchor="ctr" wrap="none" lIns="0" rIns="0" tIns="0" bIns="0"/>
+          <a:bodyPr wrap="none" lIns="0" tIns="0" rIns="0" bIns="0" rtlCol="0" anchor="ctr"/>
           <a:lstStyle/>
           <a:p>
             <a:pPr algn="ctr">
@@ -4418,7 +4009,7 @@
               </a:spcAft>
             </a:pPr>
             <a:r>
-              <a:rPr sz="1900" b="1" i="0">
+              <a:rPr sz="1900" b="1" i="0" dirty="0">
                 <a:solidFill>
                   <a:srgbClr val="FFFFFF"/>
                 </a:solidFill>
@@ -4426,7 +4017,29 @@
                 <a:ea typeface="Arial"/>
                 <a:cs typeface="Arial"/>
               </a:rPr>
-              <a:t>RViz Nav2 Costmap &amp; Global Path</a:t>
+              <a:t>RViz Nav2 </a:t>
+            </a:r>
+            <a:r>
+              <a:rPr sz="1900" b="1" i="0" dirty="0" err="1">
+                <a:solidFill>
+                  <a:srgbClr val="FFFFFF"/>
+                </a:solidFill>
+                <a:latin typeface="Arial"/>
+                <a:ea typeface="Arial"/>
+                <a:cs typeface="Arial"/>
+              </a:rPr>
+              <a:t>Costmap</a:t>
+            </a:r>
+            <a:r>
+              <a:rPr sz="1900" b="1" i="0" dirty="0">
+                <a:solidFill>
+                  <a:srgbClr val="FFFFFF"/>
+                </a:solidFill>
+                <a:latin typeface="Arial"/>
+                <a:ea typeface="Arial"/>
+                <a:cs typeface="Arial"/>
+              </a:rPr>
+              <a:t> &amp; Global Path</a:t>
             </a:r>
           </a:p>
         </p:txBody>
@@ -4439,8 +4052,8 @@
         </p:nvSpPr>
         <p:spPr>
           <a:xfrm>
-            <a:off x="936000" y="35686217"/>
-            <a:ext cx="13787999" cy="3337782"/>
+            <a:off x="936000" y="37188000"/>
+            <a:ext cx="13787999" cy="3311999"/>
           </a:xfrm>
           <a:prstGeom prst="rect">
             <a:avLst/>
@@ -4448,12 +4061,12 @@
           <a:noFill/>
         </p:spPr>
         <p:txBody>
-          <a:bodyPr wrap="square" anchor="t" lIns="0" rIns="0" tIns="0" bIns="0">
+          <a:bodyPr wrap="square" lIns="0" tIns="0" rIns="0" bIns="0" anchor="t">
             <a:noAutofit/>
           </a:bodyPr>
           <a:lstStyle/>
           <a:p>
-            <a:pPr algn="l" marL="288000" indent="-288000">
+            <a:pPr marL="288000" indent="-288000" algn="l">
               <a:lnSpc>
                 <a:spcPct val="105000"/>
               </a:lnSpc>
@@ -4461,7 +4074,7 @@
                 <a:spcPts val="0"/>
               </a:spcBef>
               <a:spcAft>
-                <a:spcPts val="300"/>
+                <a:spcPts val="450"/>
               </a:spcAft>
               <a:buClr>
                 <a:srgbClr val="1565C0"/>
@@ -4471,7 +4084,7 @@
               <a:buChar char="■"/>
             </a:pPr>
             <a:r>
-              <a:rPr sz="2400" b="1" i="0">
+              <a:rPr sz="2500" b="1" i="0" dirty="0">
                 <a:solidFill>
                   <a:srgbClr val="0F172A"/>
                 </a:solidFill>
@@ -4482,7 +4095,7 @@
               <a:t>Gait Oscillation Emulation:</a:t>
             </a:r>
             <a:r>
-              <a:rPr sz="2400" b="0" i="0">
+              <a:rPr sz="2500" b="0" i="0" dirty="0">
                 <a:solidFill>
                   <a:srgbClr val="0F172A"/>
                 </a:solidFill>
@@ -4494,7 +4107,7 @@
             </a:r>
           </a:p>
           <a:p>
-            <a:pPr algn="l" marL="288000" indent="-288000">
+            <a:pPr marL="288000" indent="-288000" algn="l">
               <a:lnSpc>
                 <a:spcPct val="105000"/>
               </a:lnSpc>
@@ -4502,7 +4115,7 @@
                 <a:spcPts val="0"/>
               </a:spcBef>
               <a:spcAft>
-                <a:spcPts val="300"/>
+                <a:spcPts val="450"/>
               </a:spcAft>
               <a:buClr>
                 <a:srgbClr val="1565C0"/>
@@ -4512,7 +4125,7 @@
               <a:buChar char="■"/>
             </a:pPr>
             <a:r>
-              <a:rPr sz="2400" b="1" i="0">
+              <a:rPr sz="2500" b="1" i="0" dirty="0">
                 <a:solidFill>
                   <a:srgbClr val="0F172A"/>
                 </a:solidFill>
@@ -4523,7 +4136,7 @@
               <a:t>RTAB-Map V-SLAM Optimization:</a:t>
             </a:r>
             <a:r>
-              <a:rPr sz="2400" b="0" i="0">
+              <a:rPr sz="2500" b="0" i="0" dirty="0">
                 <a:solidFill>
                   <a:srgbClr val="0F172A"/>
                 </a:solidFill>
@@ -4535,7 +4148,7 @@
             </a:r>
           </a:p>
           <a:p>
-            <a:pPr algn="l" marL="288000" indent="-288000">
+            <a:pPr marL="288000" indent="-288000" algn="l">
               <a:lnSpc>
                 <a:spcPct val="105000"/>
               </a:lnSpc>
@@ -4553,7 +4166,7 @@
               <a:buChar char="■"/>
             </a:pPr>
             <a:r>
-              <a:rPr sz="2500" b="1" i="0">
+              <a:rPr sz="2500" b="1" i="0" dirty="0">
                 <a:solidFill>
                   <a:srgbClr val="0F172A"/>
                 </a:solidFill>
@@ -4564,7 +4177,7 @@
               <a:t>Nav2 Local Replanning:</a:t>
             </a:r>
             <a:r>
-              <a:rPr sz="2500" b="0" i="0">
+              <a:rPr sz="2500" b="0" i="0" dirty="0">
                 <a:solidFill>
                   <a:srgbClr val="0F172A"/>
                 </a:solidFill>
@@ -4585,8 +4198,8 @@
         </p:nvSpPr>
         <p:spPr>
           <a:xfrm>
-            <a:off x="15336000" y="15947999"/>
-            <a:ext cx="14220000" cy="9504000"/>
+            <a:off x="15336000" y="16416000"/>
+            <a:ext cx="14220000" cy="9684000"/>
           </a:xfrm>
           <a:prstGeom prst="roundRect">
             <a:avLst>
@@ -4607,6 +4220,7 @@
           <a:lstStyle/>
           <a:p>
             <a:pPr algn="ctr"/>
+            <a:endParaRPr/>
           </a:p>
         </p:txBody>
       </p:sp>
@@ -4618,7 +4232,7 @@
         </p:nvSpPr>
         <p:spPr>
           <a:xfrm>
-            <a:off x="15336000" y="15947999"/>
+            <a:off x="15336000" y="16416000"/>
             <a:ext cx="14220000" cy="720000"/>
           </a:xfrm>
           <a:prstGeom prst="round2SameRect">
@@ -4635,7 +4249,7 @@
           </a:ln>
         </p:spPr>
         <p:txBody>
-          <a:bodyPr rtlCol="0" anchor="ctr" wrap="none" lIns="288000" rIns="288000" tIns="0" bIns="0"/>
+          <a:bodyPr wrap="none" lIns="288000" tIns="0" rIns="288000" bIns="0" rtlCol="0" anchor="ctr"/>
           <a:lstStyle/>
           <a:p>
             <a:pPr algn="l">
@@ -4679,7 +4293,7 @@
         </p:blipFill>
         <p:spPr>
           <a:xfrm>
-            <a:off x="15723844" y="16884000"/>
+            <a:off x="15723844" y="17370000"/>
             <a:ext cx="5637446" cy="5760000"/>
           </a:xfrm>
           <a:prstGeom prst="rect">
@@ -4695,7 +4309,7 @@
         </p:nvSpPr>
         <p:spPr>
           <a:xfrm>
-            <a:off x="15813844" y="16974000"/>
+            <a:off x="15813844" y="17460000"/>
             <a:ext cx="3553920" cy="387360"/>
           </a:xfrm>
           <a:prstGeom prst="roundRect">
@@ -4711,7 +4325,7 @@
           </a:ln>
         </p:spPr>
         <p:txBody>
-          <a:bodyPr rtlCol="0" anchor="ctr" wrap="none" lIns="0" rIns="0" tIns="0" bIns="0"/>
+          <a:bodyPr wrap="none" lIns="0" tIns="0" rIns="0" bIns="0" rtlCol="0" anchor="ctr"/>
           <a:lstStyle/>
           <a:p>
             <a:pPr algn="ctr">
@@ -4755,7 +4369,7 @@
         </p:blipFill>
         <p:spPr>
           <a:xfrm>
-            <a:off x="21541290" y="16884000"/>
+            <a:off x="21541290" y="17370000"/>
             <a:ext cx="6470808" cy="5760000"/>
           </a:xfrm>
           <a:prstGeom prst="rect">
@@ -4771,7 +4385,7 @@
         </p:nvSpPr>
         <p:spPr>
           <a:xfrm>
-            <a:off x="21631290" y="16974000"/>
+            <a:off x="21631290" y="17460000"/>
             <a:ext cx="3864960" cy="387360"/>
           </a:xfrm>
           <a:prstGeom prst="roundRect">
@@ -4787,7 +4401,7 @@
           </a:ln>
         </p:spPr>
         <p:txBody>
-          <a:bodyPr rtlCol="0" anchor="ctr" wrap="none" lIns="0" rIns="0" tIns="0" bIns="0"/>
+          <a:bodyPr wrap="none" lIns="0" tIns="0" rIns="0" bIns="0" rtlCol="0" anchor="ctr"/>
           <a:lstStyle/>
           <a:p>
             <a:pPr algn="ctr">
@@ -4831,8 +4445,8 @@
         </p:blipFill>
         <p:spPr>
           <a:xfrm>
-            <a:off x="28192099" y="17244000"/>
-            <a:ext cx="976056" cy="5400000"/>
+            <a:off x="28192099" y="17369999"/>
+            <a:ext cx="976056" cy="5760001"/>
           </a:xfrm>
           <a:prstGeom prst="rect">
             <a:avLst/>
@@ -4847,7 +4461,7 @@
         </p:nvSpPr>
         <p:spPr>
           <a:xfrm>
-            <a:off x="28397887" y="16920000"/>
+            <a:off x="28397887" y="17406000"/>
             <a:ext cx="564480" cy="357120"/>
           </a:xfrm>
           <a:prstGeom prst="roundRect">
@@ -4863,7 +4477,7 @@
           </a:ln>
         </p:spPr>
         <p:txBody>
-          <a:bodyPr rtlCol="0" anchor="ctr" wrap="none" lIns="0" rIns="0" tIns="0" bIns="0"/>
+          <a:bodyPr wrap="none" lIns="0" tIns="0" rIns="0" bIns="0" rtlCol="0" anchor="ctr"/>
           <a:lstStyle/>
           <a:p>
             <a:pPr algn="ctr">
@@ -4899,8 +4513,8 @@
         </p:nvSpPr>
         <p:spPr>
           <a:xfrm>
-            <a:off x="15552000" y="22788000"/>
-            <a:ext cx="13787999" cy="2447999"/>
+            <a:off x="15552000" y="23328000"/>
+            <a:ext cx="13787999" cy="2556000"/>
           </a:xfrm>
           <a:prstGeom prst="rect">
             <a:avLst/>
@@ -4908,12 +4522,12 @@
           <a:noFill/>
         </p:spPr>
         <p:txBody>
-          <a:bodyPr wrap="square" anchor="t" lIns="0" rIns="0" tIns="0" bIns="0">
+          <a:bodyPr wrap="square" lIns="0" tIns="0" rIns="0" bIns="0" anchor="t">
             <a:noAutofit/>
           </a:bodyPr>
           <a:lstStyle/>
           <a:p>
-            <a:pPr algn="l" marL="288000" indent="-288000">
+            <a:pPr marL="288000" indent="-288000" algn="l">
               <a:lnSpc>
                 <a:spcPct val="105000"/>
               </a:lnSpc>
@@ -4921,7 +4535,7 @@
                 <a:spcPts val="0"/>
               </a:spcBef>
               <a:spcAft>
-                <a:spcPts val="400"/>
+                <a:spcPts val="550"/>
               </a:spcAft>
               <a:buClr>
                 <a:srgbClr val="166534"/>
@@ -4954,7 +4568,7 @@
             </a:r>
           </a:p>
           <a:p>
-            <a:pPr algn="l" marL="288000" indent="-288000">
+            <a:pPr marL="288000" indent="-288000" algn="l">
               <a:lnSpc>
                 <a:spcPct val="105000"/>
               </a:lnSpc>
@@ -5004,8 +4618,8 @@
         </p:nvSpPr>
         <p:spPr>
           <a:xfrm>
-            <a:off x="15336000" y="25721999"/>
-            <a:ext cx="14220000" cy="8208000"/>
+            <a:off x="15336000" y="26460000"/>
+            <a:ext cx="14220000" cy="8532000"/>
           </a:xfrm>
           <a:prstGeom prst="roundRect">
             <a:avLst>
@@ -5026,6 +4640,7 @@
           <a:lstStyle/>
           <a:p>
             <a:pPr algn="ctr"/>
+            <a:endParaRPr/>
           </a:p>
         </p:txBody>
       </p:sp>
@@ -5037,7 +4652,7 @@
         </p:nvSpPr>
         <p:spPr>
           <a:xfrm>
-            <a:off x="15336000" y="25721999"/>
+            <a:off x="15336000" y="26460000"/>
             <a:ext cx="14220000" cy="720000"/>
           </a:xfrm>
           <a:prstGeom prst="round2SameRect">
@@ -5054,7 +4669,7 @@
           </a:ln>
         </p:spPr>
         <p:txBody>
-          <a:bodyPr rtlCol="0" anchor="ctr" wrap="none" lIns="288000" rIns="288000" tIns="0" bIns="0"/>
+          <a:bodyPr wrap="none" lIns="288000" tIns="0" rIns="288000" bIns="0" rtlCol="0" anchor="ctr"/>
           <a:lstStyle/>
           <a:p>
             <a:pPr algn="l">
@@ -5090,7 +4705,7 @@
         </p:nvSpPr>
         <p:spPr>
           <a:xfrm>
-            <a:off x="15552000" y="26657999"/>
+            <a:off x="15552000" y="27413998"/>
             <a:ext cx="6750000" cy="1872000"/>
           </a:xfrm>
           <a:prstGeom prst="roundRect">
@@ -5112,6 +4727,7 @@
           <a:lstStyle/>
           <a:p>
             <a:pPr algn="ctr"/>
+            <a:endParaRPr/>
           </a:p>
         </p:txBody>
       </p:sp>
@@ -5123,7 +4739,7 @@
         </p:nvSpPr>
         <p:spPr>
           <a:xfrm>
-            <a:off x="15624000" y="26747999"/>
+            <a:off x="15624000" y="27503998"/>
             <a:ext cx="6606000" cy="1728000"/>
           </a:xfrm>
           <a:prstGeom prst="rect">
@@ -5132,7 +4748,7 @@
           <a:noFill/>
         </p:spPr>
         <p:txBody>
-          <a:bodyPr wrap="square" anchor="t" lIns="0" rIns="0" tIns="0" bIns="0">
+          <a:bodyPr wrap="square" lIns="0" tIns="0" rIns="0" bIns="0" anchor="t">
             <a:noAutofit/>
           </a:bodyPr>
           <a:lstStyle/>
@@ -5194,7 +4810,7 @@
         </p:nvSpPr>
         <p:spPr>
           <a:xfrm>
-            <a:off x="22590000" y="26657999"/>
+            <a:off x="22590000" y="27413998"/>
             <a:ext cx="6750000" cy="1872000"/>
           </a:xfrm>
           <a:prstGeom prst="roundRect">
@@ -5216,6 +4832,7 @@
           <a:lstStyle/>
           <a:p>
             <a:pPr algn="ctr"/>
+            <a:endParaRPr/>
           </a:p>
         </p:txBody>
       </p:sp>
@@ -5227,7 +4844,7 @@
         </p:nvSpPr>
         <p:spPr>
           <a:xfrm>
-            <a:off x="22662000" y="26747999"/>
+            <a:off x="22662000" y="27503998"/>
             <a:ext cx="6606000" cy="1728000"/>
           </a:xfrm>
           <a:prstGeom prst="rect">
@@ -5236,7 +4853,7 @@
           <a:noFill/>
         </p:spPr>
         <p:txBody>
-          <a:bodyPr wrap="square" anchor="t" lIns="0" rIns="0" tIns="0" bIns="0">
+          <a:bodyPr wrap="square" lIns="0" tIns="0" rIns="0" bIns="0" anchor="t">
             <a:noAutofit/>
           </a:bodyPr>
           <a:lstStyle/>
@@ -5298,7 +4915,7 @@
         </p:nvSpPr>
         <p:spPr>
           <a:xfrm>
-            <a:off x="15552000" y="28673999"/>
+            <a:off x="15552000" y="29483999"/>
             <a:ext cx="6750000" cy="1872000"/>
           </a:xfrm>
           <a:prstGeom prst="roundRect">
@@ -5320,6 +4937,7 @@
           <a:lstStyle/>
           <a:p>
             <a:pPr algn="ctr"/>
+            <a:endParaRPr/>
           </a:p>
         </p:txBody>
       </p:sp>
@@ -5331,7 +4949,7 @@
         </p:nvSpPr>
         <p:spPr>
           <a:xfrm>
-            <a:off x="15624000" y="28763999"/>
+            <a:off x="15624000" y="29573999"/>
             <a:ext cx="6606000" cy="1728000"/>
           </a:xfrm>
           <a:prstGeom prst="rect">
@@ -5340,7 +4958,7 @@
           <a:noFill/>
         </p:spPr>
         <p:txBody>
-          <a:bodyPr wrap="square" anchor="t" lIns="0" rIns="0" tIns="0" bIns="0">
+          <a:bodyPr wrap="square" lIns="0" tIns="0" rIns="0" bIns="0" anchor="t">
             <a:noAutofit/>
           </a:bodyPr>
           <a:lstStyle/>
@@ -5402,7 +5020,7 @@
         </p:nvSpPr>
         <p:spPr>
           <a:xfrm>
-            <a:off x="22590000" y="28673999"/>
+            <a:off x="22590000" y="29483999"/>
             <a:ext cx="6750000" cy="1872000"/>
           </a:xfrm>
           <a:prstGeom prst="roundRect">
@@ -5424,6 +5042,7 @@
           <a:lstStyle/>
           <a:p>
             <a:pPr algn="ctr"/>
+            <a:endParaRPr/>
           </a:p>
         </p:txBody>
       </p:sp>
@@ -5435,7 +5054,7 @@
         </p:nvSpPr>
         <p:spPr>
           <a:xfrm>
-            <a:off x="22662000" y="28763999"/>
+            <a:off x="22662000" y="29573999"/>
             <a:ext cx="6606000" cy="1728000"/>
           </a:xfrm>
           <a:prstGeom prst="rect">
@@ -5444,7 +5063,7 @@
           <a:noFill/>
         </p:spPr>
         <p:txBody>
-          <a:bodyPr wrap="square" anchor="t" lIns="0" rIns="0" tIns="0" bIns="0">
+          <a:bodyPr wrap="square" lIns="0" tIns="0" rIns="0" bIns="0" anchor="t">
             <a:noAutofit/>
           </a:bodyPr>
           <a:lstStyle/>
@@ -5506,8 +5125,8 @@
         </p:nvSpPr>
         <p:spPr>
           <a:xfrm>
-            <a:off x="15552000" y="30761999"/>
-            <a:ext cx="13787999" cy="2952000"/>
+            <a:off x="15552000" y="31625999"/>
+            <a:ext cx="13787999" cy="3150000"/>
           </a:xfrm>
           <a:prstGeom prst="rect">
             <a:avLst/>
@@ -5515,12 +5134,12 @@
           <a:noFill/>
         </p:spPr>
         <p:txBody>
-          <a:bodyPr wrap="square" anchor="t" lIns="0" rIns="0" tIns="0" bIns="0">
+          <a:bodyPr wrap="square" lIns="0" tIns="0" rIns="0" bIns="0" anchor="t">
             <a:noAutofit/>
           </a:bodyPr>
           <a:lstStyle/>
           <a:p>
-            <a:pPr algn="l" marL="288000" indent="-288000">
+            <a:pPr marL="288000" indent="-288000" algn="l">
               <a:lnSpc>
                 <a:spcPct val="105000"/>
               </a:lnSpc>
@@ -5528,7 +5147,7 @@
                 <a:spcPts val="0"/>
               </a:spcBef>
               <a:spcAft>
-                <a:spcPts val="400"/>
+                <a:spcPts val="550"/>
               </a:spcAft>
               <a:buClr>
                 <a:srgbClr val="166534"/>
@@ -5561,7 +5180,7 @@
             </a:r>
           </a:p>
           <a:p>
-            <a:pPr algn="l" marL="288000" indent="-288000">
+            <a:pPr marL="288000" indent="-288000" algn="l">
               <a:lnSpc>
                 <a:spcPct val="105000"/>
               </a:lnSpc>
@@ -5611,8 +5230,8 @@
         </p:nvSpPr>
         <p:spPr>
           <a:xfrm>
-            <a:off x="15336000" y="34199999"/>
-            <a:ext cx="14220000" cy="5040000"/>
+            <a:off x="15336000" y="35352000"/>
+            <a:ext cx="14220000" cy="5364000"/>
           </a:xfrm>
           <a:prstGeom prst="roundRect">
             <a:avLst>
@@ -5633,6 +5252,7 @@
           <a:lstStyle/>
           <a:p>
             <a:pPr algn="ctr"/>
+            <a:endParaRPr/>
           </a:p>
         </p:txBody>
       </p:sp>
@@ -5644,7 +5264,7 @@
         </p:nvSpPr>
         <p:spPr>
           <a:xfrm>
-            <a:off x="15336000" y="34199999"/>
+            <a:off x="15336000" y="35352000"/>
             <a:ext cx="14220000" cy="720000"/>
           </a:xfrm>
           <a:prstGeom prst="round2SameRect">
@@ -5661,7 +5281,7 @@
           </a:ln>
         </p:spPr>
         <p:txBody>
-          <a:bodyPr rtlCol="0" anchor="ctr" wrap="none" lIns="288000" rIns="288000" tIns="0" bIns="0"/>
+          <a:bodyPr wrap="none" lIns="288000" tIns="0" rIns="288000" bIns="0" rtlCol="0" anchor="ctr"/>
           <a:lstStyle/>
           <a:p>
             <a:pPr algn="l">
@@ -5697,8 +5317,8 @@
         </p:nvSpPr>
         <p:spPr>
           <a:xfrm>
-            <a:off x="15552000" y="35135999"/>
-            <a:ext cx="13787999" cy="3888000"/>
+            <a:off x="15552000" y="36324000"/>
+            <a:ext cx="13787999" cy="4176000"/>
           </a:xfrm>
           <a:prstGeom prst="rect">
             <a:avLst/>
@@ -5706,12 +5326,12 @@
           <a:noFill/>
         </p:spPr>
         <p:txBody>
-          <a:bodyPr wrap="square" anchor="t" lIns="0" rIns="0" tIns="0" bIns="0">
+          <a:bodyPr wrap="square" lIns="0" tIns="0" rIns="0" bIns="0" anchor="t">
             <a:noAutofit/>
           </a:bodyPr>
           <a:lstStyle/>
           <a:p>
-            <a:pPr algn="l" marL="288000" indent="-288000">
+            <a:pPr marL="288000" indent="-288000" algn="l">
               <a:lnSpc>
                 <a:spcPct val="105000"/>
               </a:lnSpc>
@@ -5719,7 +5339,7 @@
                 <a:spcPts val="0"/>
               </a:spcBef>
               <a:spcAft>
-                <a:spcPts val="300"/>
+                <a:spcPts val="500"/>
               </a:spcAft>
               <a:buClr>
                 <a:srgbClr val="0B2545"/>
@@ -5729,7 +5349,7 @@
               <a:buChar char="■"/>
             </a:pPr>
             <a:r>
-              <a:rPr sz="2500" b="1" i="0">
+              <a:rPr sz="2500" b="1" i="0" dirty="0">
                 <a:solidFill>
                   <a:srgbClr val="0F172A"/>
                 </a:solidFill>
@@ -5740,7 +5360,7 @@
               <a:t>Practical Virtual Sandbox:</a:t>
             </a:r>
             <a:r>
-              <a:rPr sz="2500" b="0" i="0">
+              <a:rPr sz="2500" b="0" i="0" dirty="0">
                 <a:solidFill>
                   <a:srgbClr val="0F172A"/>
                 </a:solidFill>
@@ -5752,7 +5372,7 @@
             </a:r>
           </a:p>
           <a:p>
-            <a:pPr algn="l" marL="288000" indent="-288000">
+            <a:pPr marL="288000" indent="-288000" algn="l">
               <a:lnSpc>
                 <a:spcPct val="105000"/>
               </a:lnSpc>
@@ -5760,7 +5380,7 @@
                 <a:spcPts val="0"/>
               </a:spcBef>
               <a:spcAft>
-                <a:spcPts val="300"/>
+                <a:spcPts val="500"/>
               </a:spcAft>
               <a:buClr>
                 <a:srgbClr val="0B2545"/>
@@ -5770,7 +5390,7 @@
               <a:buChar char="■"/>
             </a:pPr>
             <a:r>
-              <a:rPr sz="2500" b="1" i="0">
+              <a:rPr sz="2500" b="1" i="0" dirty="0">
                 <a:solidFill>
                   <a:srgbClr val="0F172A"/>
                 </a:solidFill>
@@ -5781,7 +5401,7 @@
               <a:t>Decoupled Edge Efficiency:</a:t>
             </a:r>
             <a:r>
-              <a:rPr sz="2500" b="0" i="0">
+              <a:rPr sz="2500" b="0" i="0" dirty="0">
                 <a:solidFill>
                   <a:srgbClr val="0F172A"/>
                 </a:solidFill>
@@ -5793,7 +5413,7 @@
             </a:r>
           </a:p>
           <a:p>
-            <a:pPr algn="l" marL="288000" indent="-288000">
+            <a:pPr marL="288000" indent="-288000" algn="l">
               <a:lnSpc>
                 <a:spcPct val="105000"/>
               </a:lnSpc>
@@ -5811,7 +5431,7 @@
               <a:buChar char="■"/>
             </a:pPr>
             <a:r>
-              <a:rPr sz="2500" b="1" i="0">
+              <a:rPr sz="2500" b="1" i="0" dirty="0">
                 <a:solidFill>
                   <a:srgbClr val="0F172A"/>
                 </a:solidFill>
@@ -5822,7 +5442,7 @@
               <a:t>Future Research:</a:t>
             </a:r>
             <a:r>
-              <a:rPr sz="2500" b="0" i="0">
+              <a:rPr sz="2500" b="0" i="0" dirty="0">
                 <a:solidFill>
                   <a:srgbClr val="0F172A"/>
                 </a:solidFill>
@@ -5843,7 +5463,7 @@
         </p:nvSpPr>
         <p:spPr>
           <a:xfrm>
-            <a:off x="720000" y="39456000"/>
+            <a:off x="720000" y="40968000"/>
             <a:ext cx="28835999" cy="28800"/>
           </a:xfrm>
           <a:prstGeom prst="rect">
@@ -5861,6 +5481,7 @@
           <a:lstStyle/>
           <a:p>
             <a:pPr algn="ctr"/>
+            <a:endParaRPr/>
           </a:p>
         </p:txBody>
       </p:sp>
@@ -5872,8 +5493,8 @@
         </p:nvSpPr>
         <p:spPr>
           <a:xfrm>
-            <a:off x="720000" y="39672000"/>
-            <a:ext cx="26711999" cy="1872000"/>
+            <a:off x="720000" y="41155200"/>
+            <a:ext cx="28835999" cy="827999"/>
           </a:xfrm>
           <a:prstGeom prst="rect">
             <a:avLst/>
@@ -5881,32 +5502,54 @@
           <a:noFill/>
         </p:spPr>
         <p:txBody>
-          <a:bodyPr wrap="square" anchor="t" lIns="0" rIns="0" tIns="0" bIns="0">
+          <a:bodyPr wrap="square" lIns="0" tIns="0" rIns="0" bIns="0" anchor="t">
             <a:noAutofit/>
           </a:bodyPr>
           <a:lstStyle/>
           <a:p>
             <a:pPr algn="l">
               <a:lnSpc>
-                <a:spcPct val="105000"/>
+                <a:spcPct val="115000"/>
               </a:lnSpc>
               <a:spcBef>
                 <a:spcPts val="0"/>
               </a:spcBef>
               <a:spcAft>
-                <a:spcPts val="300"/>
+                <a:spcPts val="200"/>
               </a:spcAft>
             </a:pPr>
             <a:r>
               <a:rPr sz="2200" b="1" i="0">
                 <a:solidFill>
+                  <a:srgbClr val="0B2545"/>
+                </a:solidFill>
+                <a:latin typeface="Arial"/>
+                <a:ea typeface="Arial"/>
+                <a:cs typeface="Arial"/>
+              </a:rPr>
+              <a:t>References:  </a:t>
+            </a:r>
+            <a:r>
+              <a:rPr sz="2200" b="0" i="0">
+                <a:solidFill>
                   <a:srgbClr val="475569"/>
                 </a:solidFill>
                 <a:latin typeface="Arial"/>
                 <a:ea typeface="Arial"/>
                 <a:cs typeface="Arial"/>
               </a:rPr>
-              <a:t>References:</a:t>
+              <a:t>[1] B. Kerbl et al., “3D Gaussian splatting for real-time radiance field rendering,” </a:t>
+            </a:r>
+            <a:r>
+              <a:rPr sz="2200" b="0" i="1">
+                <a:solidFill>
+                  <a:srgbClr val="475569"/>
+                </a:solidFill>
+                <a:latin typeface="Arial"/>
+                <a:ea typeface="Arial"/>
+                <a:cs typeface="Arial"/>
+              </a:rPr>
+              <a:t>ACM TOG</a:t>
             </a:r>
             <a:r>
               <a:rPr sz="2200" b="0" i="0">
@@ -5917,7 +5560,7 @@
                 <a:ea typeface="Arial"/>
                 <a:cs typeface="Arial"/>
               </a:rPr>
-              <a:t>  [1] B. Kerbl et al., “3D Gaussian splatting for real-time radiance field rendering,” </a:t>
+              <a:t>, 2023.    [2] M. Labbé &amp; F. Michaud, “RTAB-Map as an open-source lidar and visual SLAM library,” </a:t>
             </a:r>
             <a:r>
               <a:rPr sz="2200" b="0" i="1">
@@ -5928,7 +5571,7 @@
                 <a:ea typeface="Arial"/>
                 <a:cs typeface="Arial"/>
               </a:rPr>
-              <a:t>ACM TOG</a:t>
+              <a:t>arXiv:2403.06341</a:t>
             </a:r>
             <a:r>
               <a:rPr sz="2200" b="0" i="0">
@@ -5939,79 +5582,13 @@
                 <a:ea typeface="Arial"/>
                 <a:cs typeface="Arial"/>
               </a:rPr>
-              <a:t>, 2023.  [2] M. Labbé &amp; F. Michaud, “RTAB-Map as an open-source lidar and visual SLAM library,” </a:t>
-            </a:r>
-            <a:r>
-              <a:rPr sz="2200" b="0" i="1">
-                <a:solidFill>
-                  <a:srgbClr val="475569"/>
-                </a:solidFill>
-                <a:latin typeface="Arial"/>
-                <a:ea typeface="Arial"/>
-                <a:cs typeface="Arial"/>
-              </a:rPr>
-              <a:t>arXiv:2403.06341</a:t>
-            </a:r>
-            <a:r>
-              <a:rPr sz="2200" b="0" i="0">
-                <a:solidFill>
-                  <a:srgbClr val="475569"/>
-                </a:solidFill>
-                <a:latin typeface="Arial"/>
-                <a:ea typeface="Arial"/>
-                <a:cs typeface="Arial"/>
-              </a:rPr>
-              <a:t>, 2024.  [3] S. Macenski et al., “Robot Operating System 2: Design and architecture,” </a:t>
-            </a:r>
-            <a:r>
-              <a:rPr sz="2200" b="0" i="1">
-                <a:solidFill>
-                  <a:srgbClr val="475569"/>
-                </a:solidFill>
-                <a:latin typeface="Arial"/>
-                <a:ea typeface="Arial"/>
-                <a:cs typeface="Arial"/>
-              </a:rPr>
-              <a:t>Science Robotics</a:t>
-            </a:r>
-            <a:r>
-              <a:rPr sz="2200" b="0" i="0">
-                <a:solidFill>
-                  <a:srgbClr val="475569"/>
-                </a:solidFill>
-                <a:latin typeface="Arial"/>
-                <a:ea typeface="Arial"/>
-                <a:cs typeface="Arial"/>
-              </a:rPr>
-              <a:t>, 2022.  [4] S. Zhu et al., “VR-Robo: Real-to-sim-to-real for visual robot navigation,” </a:t>
-            </a:r>
-            <a:r>
-              <a:rPr sz="2200" b="0" i="1">
-                <a:solidFill>
-                  <a:srgbClr val="475569"/>
-                </a:solidFill>
-                <a:latin typeface="Arial"/>
-                <a:ea typeface="Arial"/>
-                <a:cs typeface="Arial"/>
-              </a:rPr>
-              <a:t>IEEE RA-L</a:t>
-            </a:r>
-            <a:r>
-              <a:rPr sz="2200" b="0" i="0">
-                <a:solidFill>
-                  <a:srgbClr val="475569"/>
-                </a:solidFill>
-                <a:latin typeface="Arial"/>
-                <a:ea typeface="Arial"/>
-                <a:cs typeface="Arial"/>
-              </a:rPr>
-              <a:t>, 2025.</a:t>
-            </a:r>
-          </a:p>
-          <a:p>
-            <a:pPr algn="l">
+              <a:t>, 2024.</a:t>
+            </a:r>
+          </a:p>
+          <a:p>
+            <a:pPr algn="l" marL="1745999">
               <a:lnSpc>
-                <a:spcPct val="105000"/>
+                <a:spcPct val="115000"/>
               </a:lnSpc>
               <a:spcBef>
                 <a:spcPts val="0"/>
@@ -6021,33 +5598,220 @@
               </a:spcAft>
             </a:pPr>
             <a:r>
-              <a:rPr sz="2200" b="1" i="0">
-                <a:solidFill>
-                  <a:srgbClr val="0B2545"/>
-                </a:solidFill>
-                <a:latin typeface="Arial"/>
-                <a:ea typeface="Arial"/>
-                <a:cs typeface="Arial"/>
-              </a:rPr>
-              <a:t>Acknowledgement:</a:t>
-            </a:r>
-            <a:r>
-              <a:rPr sz="2200" b="1" i="0">
-                <a:solidFill>
-                  <a:srgbClr val="0B2545"/>
-                </a:solidFill>
-                <a:latin typeface="Arial"/>
-                <a:ea typeface="Arial"/>
-                <a:cs typeface="Arial"/>
-              </a:rPr>
-              <a:t> This research was supported by the National Research Foundation of Korea (NRF) grant funded by the Korean government (MSIT) (No. RS-2025-24683458).</a:t>
-            </a:r>
+              <a:rPr sz="2200" b="0" i="0">
+                <a:solidFill>
+                  <a:srgbClr val="475569"/>
+                </a:solidFill>
+                <a:latin typeface="Arial"/>
+                <a:ea typeface="Arial"/>
+                <a:cs typeface="Arial"/>
+              </a:rPr>
+              <a:t>[3] S. Macenski et al., “Robot Operating System 2: Design and architecture,” </a:t>
+            </a:r>
+            <a:r>
+              <a:rPr sz="2200" b="0" i="1">
+                <a:solidFill>
+                  <a:srgbClr val="475569"/>
+                </a:solidFill>
+                <a:latin typeface="Arial"/>
+                <a:ea typeface="Arial"/>
+                <a:cs typeface="Arial"/>
+              </a:rPr>
+              <a:t>Science Robotics</a:t>
+            </a:r>
+            <a:r>
+              <a:rPr sz="2200" b="0" i="0">
+                <a:solidFill>
+                  <a:srgbClr val="475569"/>
+                </a:solidFill>
+                <a:latin typeface="Arial"/>
+                <a:ea typeface="Arial"/>
+                <a:cs typeface="Arial"/>
+              </a:rPr>
+              <a:t>, 2022.    [4] S. Zhu et al., “VR-Robo: Real-to-sim-to-real for visual robot navigation,” </a:t>
+            </a:r>
+            <a:r>
+              <a:rPr sz="2200" b="0" i="1">
+                <a:solidFill>
+                  <a:srgbClr val="475569"/>
+                </a:solidFill>
+                <a:latin typeface="Arial"/>
+                <a:ea typeface="Arial"/>
+                <a:cs typeface="Arial"/>
+              </a:rPr>
+              <a:t>IEEE RA-L</a:t>
+            </a:r>
+            <a:r>
+              <a:rPr sz="2200" b="0" i="0">
+                <a:solidFill>
+                  <a:srgbClr val="475569"/>
+                </a:solidFill>
+                <a:latin typeface="Arial"/>
+                <a:ea typeface="Arial"/>
+                <a:cs typeface="Arial"/>
+              </a:rPr>
+              <a:t>, 2025.</a:t>
+            </a:r>
+          </a:p>
+        </p:txBody>
+      </p:sp>
+      <p:sp>
+        <p:nvSpPr>
+          <p:cNvPr id="58" name="Rectangle 57"/>
+          <p:cNvSpPr/>
+          <p:nvPr/>
+        </p:nvSpPr>
+        <p:spPr>
+          <a:xfrm>
+            <a:off x="720000" y="521999"/>
+            <a:ext cx="28835999" cy="864000"/>
+          </a:xfrm>
+          <a:prstGeom prst="rect">
+            <a:avLst/>
+          </a:prstGeom>
+          <a:solidFill>
+            <a:srgbClr val="4472C4"/>
+          </a:solidFill>
+          <a:ln>
+            <a:noFill/>
+          </a:ln>
+        </p:spPr>
+        <p:txBody>
+          <a:bodyPr rtlCol="0" anchor="ctr"/>
+          <a:lstStyle/>
+          <a:p>
+            <a:pPr algn="ctr"/>
+          </a:p>
+        </p:txBody>
+      </p:sp>
+      <p:sp>
+        <p:nvSpPr>
+          <p:cNvPr id="59" name="TextBox 58"/>
+          <p:cNvSpPr txBox="1"/>
+          <p:nvPr/>
+        </p:nvSpPr>
+        <p:spPr>
+          <a:xfrm>
+            <a:off x="1007999" y="521999"/>
+            <a:ext cx="12600000" cy="864000"/>
+          </a:xfrm>
+          <a:prstGeom prst="rect">
+            <a:avLst/>
+          </a:prstGeom>
+          <a:noFill/>
+        </p:spPr>
+        <p:txBody>
+          <a:bodyPr wrap="square" anchor="ctr" lIns="0" rIns="0" tIns="0" bIns="0">
+            <a:noAutofit/>
+          </a:bodyPr>
+          <a:lstStyle/>
+          <a:p>
+            <a:pPr algn="l"/>
+            <a:r>
+              <a:rPr sz="4200" b="1">
+                <a:solidFill>
+                  <a:srgbClr val="FFFFFF"/>
+                </a:solidFill>
+                <a:latin typeface="Arial"/>
+                <a:ea typeface="Arial"/>
+                <a:cs typeface="Arial"/>
+              </a:rPr>
+              <a:t>ICCAS 2026 Poster [</a:t>
+            </a:r>
+            <a:r>
+              <a:rPr sz="4200" b="1">
+                <a:solidFill>
+                  <a:srgbClr val="FFFF00"/>
+                </a:solidFill>
+                <a:latin typeface="Arial"/>
+                <a:ea typeface="Arial"/>
+                <a:cs typeface="Arial"/>
+              </a:rPr>
+              <a:t>FrPo6P.32</a:t>
+            </a:r>
+            <a:r>
+              <a:rPr sz="4200" b="1">
+                <a:solidFill>
+                  <a:srgbClr val="FFFFFF"/>
+                </a:solidFill>
+                <a:latin typeface="Arial"/>
+                <a:ea typeface="Arial"/>
+                <a:cs typeface="Arial"/>
+              </a:rPr>
+              <a:t>]</a:t>
+            </a:r>
+          </a:p>
+        </p:txBody>
+      </p:sp>
+      <p:sp>
+        <p:nvSpPr>
+          <p:cNvPr id="60" name="TextBox 59"/>
+          <p:cNvSpPr txBox="1"/>
+          <p:nvPr/>
+        </p:nvSpPr>
+        <p:spPr>
+          <a:xfrm>
+            <a:off x="13680000" y="521999"/>
+            <a:ext cx="15587999" cy="864000"/>
+          </a:xfrm>
+          <a:prstGeom prst="rect">
+            <a:avLst/>
+          </a:prstGeom>
+          <a:noFill/>
+        </p:spPr>
+        <p:txBody>
+          <a:bodyPr wrap="square" anchor="ctr" lIns="0" rIns="0" tIns="0" bIns="0">
+            <a:noAutofit/>
+          </a:bodyPr>
+          <a:lstStyle/>
+          <a:p>
+            <a:pPr algn="r"/>
+            <a:r>
+              <a:rPr sz="2400" b="1">
+                <a:solidFill>
+                  <a:srgbClr val="FFFFFF"/>
+                </a:solidFill>
+                <a:latin typeface="Arial"/>
+                <a:ea typeface="Arial"/>
+                <a:cs typeface="Arial"/>
+              </a:rPr>
+              <a:t>Computer Graphics and Vision Lab (CGV)  ·  Handong Global University</a:t>
+            </a:r>
+          </a:p>
+        </p:txBody>
+      </p:sp>
+      <p:sp>
+        <p:nvSpPr>
+          <p:cNvPr id="61" name="Rectangle 60"/>
+          <p:cNvSpPr/>
+          <p:nvPr/>
+        </p:nvSpPr>
+        <p:spPr>
+          <a:xfrm>
+            <a:off x="720000" y="1494000"/>
+            <a:ext cx="28835999" cy="2880000"/>
+          </a:xfrm>
+          <a:prstGeom prst="rect">
+            <a:avLst/>
+          </a:prstGeom>
+          <a:solidFill>
+            <a:srgbClr val="DEEBF7"/>
+          </a:solidFill>
+          <a:ln>
+            <a:noFill/>
+          </a:ln>
+        </p:spPr>
+        <p:txBody>
+          <a:bodyPr rtlCol="0" anchor="ctr"/>
+          <a:lstStyle/>
+          <a:p>
+            <a:pPr algn="ctr"/>
           </a:p>
         </p:txBody>
       </p:sp>
       <p:pic>
         <p:nvPicPr>
-          <p:cNvPr id="54" name="Picture 53" descr="qr_repo.png"/>
+          <p:cNvPr id="62" name="Picture 61" descr="image.png"/>
           <p:cNvPicPr>
             <a:picLocks noChangeAspect="1"/>
           </p:cNvPicPr>
@@ -6061,8 +5825,8 @@
         </p:blipFill>
         <p:spPr>
           <a:xfrm>
-            <a:off x="27971999" y="39672000"/>
-            <a:ext cx="1584000" cy="1584000"/>
+            <a:off x="23490000" y="2285287"/>
+            <a:ext cx="5760000" cy="1297425"/>
           </a:xfrm>
           <a:prstGeom prst="rect">
             <a:avLst/>
@@ -6071,14 +5835,14 @@
       </p:pic>
       <p:sp>
         <p:nvSpPr>
-          <p:cNvPr id="55" name="TextBox 54"/>
+          <p:cNvPr id="63" name="TextBox 62"/>
           <p:cNvSpPr txBox="1"/>
           <p:nvPr/>
         </p:nvSpPr>
         <p:spPr>
           <a:xfrm>
-            <a:off x="27791999" y="41274000"/>
-            <a:ext cx="1944000" cy="216000"/>
+            <a:off x="1007999" y="1612799"/>
+            <a:ext cx="22104000" cy="1548000"/>
           </a:xfrm>
           <a:prstGeom prst="rect">
             <a:avLst/>
@@ -6091,19 +5855,50 @@
           </a:bodyPr>
           <a:lstStyle/>
           <a:p>
-            <a:pPr algn="ctr">
+            <a:pPr algn="l">
               <a:lnSpc>
-                <a:spcPct val="105000"/>
+                <a:spcPct val="102000"/>
               </a:lnSpc>
-              <a:spcBef>
-                <a:spcPts val="0"/>
-              </a:spcBef>
-              <a:spcAft>
-                <a:spcPts val="400"/>
-              </a:spcAft>
             </a:pPr>
             <a:r>
-              <a:rPr sz="1800" b="1" i="0">
+              <a:rPr sz="5400" b="1">
+                <a:solidFill>
+                  <a:srgbClr val="000000"/>
+                </a:solidFill>
+                <a:latin typeface="Arial"/>
+                <a:ea typeface="Arial"/>
+                <a:cs typeface="Arial"/>
+              </a:rPr>
+              <a:t>Bridging the Sim-to-Real Gap in Quadrupedal Visual Navigation via 3D Gaussian Splatting</a:t>
+            </a:r>
+          </a:p>
+        </p:txBody>
+      </p:sp>
+      <p:sp>
+        <p:nvSpPr>
+          <p:cNvPr id="64" name="TextBox 63"/>
+          <p:cNvSpPr txBox="1"/>
+          <p:nvPr/>
+        </p:nvSpPr>
+        <p:spPr>
+          <a:xfrm>
+            <a:off x="1007999" y="3329999"/>
+            <a:ext cx="22104000" cy="503999"/>
+          </a:xfrm>
+          <a:prstGeom prst="rect">
+            <a:avLst/>
+          </a:prstGeom>
+          <a:noFill/>
+        </p:spPr>
+        <p:txBody>
+          <a:bodyPr wrap="square" anchor="t" lIns="0" rIns="0" tIns="0" bIns="0">
+            <a:noAutofit/>
+          </a:bodyPr>
+          <a:lstStyle/>
+          <a:p>
+            <a:pPr algn="l"/>
+            <a:r>
+              <a:rPr sz="3200" b="1">
                 <a:solidFill>
                   <a:srgbClr val="0B2545"/>
                 </a:solidFill>
@@ -6111,7 +5906,154 @@
                 <a:ea typeface="Arial"/>
                 <a:cs typeface="Arial"/>
               </a:rPr>
-              <a:t>GitHub Repo &amp; Code</a:t>
+              <a:t>Minseok Lee</a:t>
+            </a:r>
+            <a:r>
+              <a:rPr sz="3200" b="1" baseline="30000">
+                <a:solidFill>
+                  <a:srgbClr val="0B2545"/>
+                </a:solidFill>
+                <a:latin typeface="Arial"/>
+                <a:ea typeface="Arial"/>
+                <a:cs typeface="Arial"/>
+              </a:rPr>
+              <a:t>1</a:t>
+            </a:r>
+            <a:r>
+              <a:rPr sz="3200" b="1">
+                <a:solidFill>
+                  <a:srgbClr val="0B2545"/>
+                </a:solidFill>
+                <a:latin typeface="Arial"/>
+                <a:ea typeface="Arial"/>
+                <a:cs typeface="Arial"/>
+              </a:rPr>
+              <a:t>,  Seongyu Han</a:t>
+            </a:r>
+            <a:r>
+              <a:rPr sz="3200" b="1" baseline="30000">
+                <a:solidFill>
+                  <a:srgbClr val="0B2545"/>
+                </a:solidFill>
+                <a:latin typeface="Arial"/>
+                <a:ea typeface="Arial"/>
+                <a:cs typeface="Arial"/>
+              </a:rPr>
+              <a:t>1</a:t>
+            </a:r>
+            <a:r>
+              <a:rPr sz="3200" b="1">
+                <a:solidFill>
+                  <a:srgbClr val="0B2545"/>
+                </a:solidFill>
+                <a:latin typeface="Arial"/>
+                <a:ea typeface="Arial"/>
+                <a:cs typeface="Arial"/>
+              </a:rPr>
+              <a:t>,  Heejae Moon</a:t>
+            </a:r>
+            <a:r>
+              <a:rPr sz="3200" b="1" baseline="30000">
+                <a:solidFill>
+                  <a:srgbClr val="0B2545"/>
+                </a:solidFill>
+                <a:latin typeface="Arial"/>
+                <a:ea typeface="Arial"/>
+                <a:cs typeface="Arial"/>
+              </a:rPr>
+              <a:t>1</a:t>
+            </a:r>
+            <a:r>
+              <a:rPr sz="3200" b="1">
+                <a:solidFill>
+                  <a:srgbClr val="0B2545"/>
+                </a:solidFill>
+                <a:latin typeface="Arial"/>
+                <a:ea typeface="Arial"/>
+                <a:cs typeface="Arial"/>
+              </a:rPr>
+              <a:t>,  and  Sung Soo Hwang</a:t>
+            </a:r>
+            <a:r>
+              <a:rPr sz="3200" b="1" baseline="30000">
+                <a:solidFill>
+                  <a:srgbClr val="0B2545"/>
+                </a:solidFill>
+                <a:latin typeface="Arial"/>
+                <a:ea typeface="Arial"/>
+                <a:cs typeface="Arial"/>
+              </a:rPr>
+              <a:t>1*</a:t>
+            </a:r>
+          </a:p>
+        </p:txBody>
+      </p:sp>
+      <p:sp>
+        <p:nvSpPr>
+          <p:cNvPr id="65" name="TextBox 64"/>
+          <p:cNvSpPr txBox="1"/>
+          <p:nvPr/>
+        </p:nvSpPr>
+        <p:spPr>
+          <a:xfrm>
+            <a:off x="1007999" y="3880800"/>
+            <a:ext cx="28260000" cy="396000"/>
+          </a:xfrm>
+          <a:prstGeom prst="rect">
+            <a:avLst/>
+          </a:prstGeom>
+          <a:noFill/>
+        </p:spPr>
+        <p:txBody>
+          <a:bodyPr wrap="square" anchor="t" lIns="0" rIns="0" tIns="0" bIns="0">
+            <a:noAutofit/>
+          </a:bodyPr>
+          <a:lstStyle/>
+          <a:p>
+            <a:pPr algn="l"/>
+            <a:r>
+              <a:rPr sz="2200" b="0" baseline="30000">
+                <a:solidFill>
+                  <a:srgbClr val="1E293B"/>
+                </a:solidFill>
+                <a:latin typeface="Arial"/>
+                <a:ea typeface="Arial"/>
+                <a:cs typeface="Arial"/>
+              </a:rPr>
+              <a:t>1</a:t>
+            </a:r>
+            <a:r>
+              <a:rPr sz="2200" b="0">
+                <a:solidFill>
+                  <a:srgbClr val="1E293B"/>
+                </a:solidFill>
+                <a:latin typeface="Arial"/>
+                <a:ea typeface="Arial"/>
+                <a:cs typeface="Arial"/>
+              </a:rPr>
+              <a:t>School of Artificial Intelligence, Computer and Electrical Engineering, Handong Global University, Pohang 37554, Korea   ·   </a:t>
+            </a:r>
+            <a:r>
+              <a:rPr sz="2200" b="1" baseline="30000">
+                <a:solidFill>
+                  <a:srgbClr val="0B2545"/>
+                </a:solidFill>
+                <a:latin typeface="Arial"/>
+                <a:ea typeface="Arial"/>
+                <a:cs typeface="Arial"/>
+              </a:rPr>
+              <a:t>*</a:t>
+            </a:r>
+            <a:r>
+              <a:rPr sz="2200" b="1">
+                <a:solidFill>
+                  <a:srgbClr val="0B2545"/>
+                </a:solidFill>
+                <a:latin typeface="Arial"/>
+                <a:ea typeface="Arial"/>
+                <a:cs typeface="Arial"/>
+              </a:rPr>
+              <a:t>sshwang@handong.edu</a:t>
             </a:r>
           </a:p>
         </p:txBody>

</xml_diff>